<commit_message>
Slide 8: 4C, STP and 4P in one table
Co-Authored-By: Claude Opus 5.5 <noreply@anthropic.com>
Claude-Session: https://claude.ai/code/session_01Cx9kswyecF7JAB1Rr5vVcV
</commit_message>
<xml_diff>
--- a/nedp_deck/v4/Slide08_Strategic_4C_STP_4P.pptx
+++ b/nedp_deck/v4/Slide08_Strategic_4C_STP_4P.pptx
@@ -6,7 +6,6 @@
   </p:sldMasterIdLst>
   <p:sldIdLst>
     <p:sldId id="263" r:id="rId14"/>
-    <p:sldId id="264" r:id="rId15"/>
   </p:sldIdLst>
   <p:sldSz cx="12192000" cy="6858000" type="screen4x3"/>
   <p:notesSz cx="6858000" cy="9144000"/>
@@ -3369,7 +3368,7 @@
                 </a:solidFill>
                 <a:latin typeface="Arial"/>
               </a:rPr>
-              <a:t>08 / 19</a:t>
+              <a:t>08 / 18</a:t>
             </a:r>
           </a:p>
         </p:txBody>
@@ -3384,7 +3383,7 @@
         </p:nvGraphicFramePr>
         <p:xfrm>
           <a:off x="533400" y="1504950"/>
-          <a:ext cx="11125200" cy="4933950"/>
+          <a:ext cx="11125200" cy="4910132"/>
         </p:xfrm>
         <a:graphic>
           <a:graphicData uri="http://schemas.openxmlformats.org/drawingml/2006/table">
@@ -3398,7 +3397,7 @@
                 <a:gridCol w="3143250"/>
                 <a:gridCol w="5886450"/>
               </a:tblGrid>
-              <a:tr h="266700">
+              <a:tr h="247650">
                 <a:tc>
                   <a:txBody>
                     <a:bodyPr wrap="square"/>
@@ -3584,7 +3583,7 @@
                   </a:tcPr>
                 </a:tc>
               </a:tr>
-              <a:tr h="666750">
+              <a:tr h="423862">
                 <a:tc rowSpan="4">
                   <a:txBody>
                     <a:bodyPr wrap="square"/>
@@ -3635,10 +3634,10 @@
                     <a:lstStyle/>
                     <a:p>
                       <a:pPr algn="l">
-                        <a:defRPr sz="1050"/>
+                        <a:defRPr sz="1000"/>
                       </a:pPr>
                       <a:r>
-                        <a:rPr sz="1050" b="1">
+                        <a:rPr sz="1000" b="1">
                           <a:solidFill>
                             <a:srgbClr val="11181C"/>
                           </a:solidFill>
@@ -3646,51 +3645,7 @@
                         </a:rPr>
                         <a:t>Change</a:t>
                       </a:r>
-                      <a:endParaRPr sz="1050"/>
-                    </a:p>
-                  </a:txBody>
-                  <a:tcPr marL="50800" marR="50800" marT="25400" marB="25400" anchor="ctr">
-                    <a:lnL w="9525">
-                      <a:solidFill>
-                        <a:srgbClr val="E6E8EB"/>
-                      </a:solidFill>
-                    </a:lnL>
-                    <a:lnR w="9525">
-                      <a:solidFill>
-                        <a:srgbClr val="E6E8EB"/>
-                      </a:solidFill>
-                    </a:lnR>
-                    <a:lnT w="9525">
-                      <a:solidFill>
-                        <a:srgbClr val="E6E8EB"/>
-                      </a:solidFill>
-                    </a:lnT>
-                    <a:lnB w="9525">
-                      <a:solidFill>
-                        <a:srgbClr val="E6E8EB"/>
-                      </a:solidFill>
-                    </a:lnB>
-                    <a:noFill/>
-                  </a:tcPr>
-                </a:tc>
-                <a:tc>
-                  <a:txBody>
-                    <a:bodyPr wrap="square"/>
-                    <a:lstStyle/>
-                    <a:p>
-                      <a:pPr algn="l">
-                        <a:defRPr sz="1050"/>
-                      </a:pPr>
-                      <a:r>
-                        <a:rPr sz="1050" b="1">
-                          <a:solidFill>
-                            <a:srgbClr val="11181C"/>
-                          </a:solidFill>
-                          <a:latin typeface="Arial"/>
-                        </a:rPr>
-                        <a:t>HYVA has left; value sits in Medium + Heavy</a:t>
-                      </a:r>
-                      <a:endParaRPr sz="1050"/>
+                      <a:endParaRPr sz="1000"/>
                     </a:p>
                   </a:txBody>
                   <a:tcPr marL="50800" marR="50800" marT="25400" marB="25400" anchor="ctr">
@@ -3726,90 +3681,15 @@
                         <a:defRPr sz="1000"/>
                       </a:pPr>
                       <a:r>
-                        <a:rPr sz="1000" b="0">
+                        <a:rPr sz="1000" b="1">
                           <a:solidFill>
                             <a:srgbClr val="11181C"/>
                           </a:solidFill>
                           <a:latin typeface="Arial"/>
                         </a:rPr>
-                        <a:t>Triatra has no crane brand since HYVA stopped. Medium + Heavy = 41% of units, 64% of value (2023 – 2026). Heavy units 12 → 17 → 35 (2023 – 2025).</a:t>
+                        <a:t>HYVA has left; value sits in Medium + Heavy</a:t>
                       </a:r>
                       <a:endParaRPr sz="1000"/>
-                    </a:p>
-                  </a:txBody>
-                  <a:tcPr marL="50800" marR="50800" marT="25400" marB="25400" anchor="ctr">
-                    <a:lnL w="9525">
-                      <a:solidFill>
-                        <a:srgbClr val="E6E8EB"/>
-                      </a:solidFill>
-                    </a:lnL>
-                    <a:lnR w="9525">
-                      <a:solidFill>
-                        <a:srgbClr val="E6E8EB"/>
-                      </a:solidFill>
-                    </a:lnR>
-                    <a:lnT w="9525">
-                      <a:solidFill>
-                        <a:srgbClr val="E6E8EB"/>
-                      </a:solidFill>
-                    </a:lnT>
-                    <a:lnB w="9525">
-                      <a:solidFill>
-                        <a:srgbClr val="E6E8EB"/>
-                      </a:solidFill>
-                    </a:lnB>
-                    <a:noFill/>
-                  </a:tcPr>
-                </a:tc>
-              </a:tr>
-              <a:tr h="666750">
-                <a:tc vMerge="1">
-                  <a:txBody>
-                    <a:bodyPr/>
-                    <a:lstStyle/>
-                    <a:p/>
-                  </a:txBody>
-                  <a:tcPr>
-                    <a:lnL w="9525">
-                      <a:solidFill>
-                        <a:srgbClr val="E6E8EB"/>
-                      </a:solidFill>
-                    </a:lnL>
-                    <a:lnR w="9525">
-                      <a:solidFill>
-                        <a:srgbClr val="E6E8EB"/>
-                      </a:solidFill>
-                    </a:lnR>
-                    <a:lnT w="9525">
-                      <a:solidFill>
-                        <a:srgbClr val="E6E8EB"/>
-                      </a:solidFill>
-                    </a:lnT>
-                    <a:lnB w="9525">
-                      <a:solidFill>
-                        <a:srgbClr val="E6E8EB"/>
-                      </a:solidFill>
-                    </a:lnB>
-                  </a:tcPr>
-                </a:tc>
-                <a:tc>
-                  <a:txBody>
-                    <a:bodyPr wrap="square"/>
-                    <a:lstStyle/>
-                    <a:p>
-                      <a:pPr algn="l">
-                        <a:defRPr sz="1050"/>
-                      </a:pPr>
-                      <a:r>
-                        <a:rPr sz="1050" b="1">
-                          <a:solidFill>
-                            <a:srgbClr val="11181C"/>
-                          </a:solidFill>
-                          <a:latin typeface="Arial"/>
-                        </a:rPr>
-                        <a:t>Competitor</a:t>
-                      </a:r>
-                      <a:endParaRPr sz="1050"/>
                     </a:p>
                   </a:txBody>
                   <a:tcPr marL="50800" marR="50800" marT="25400" marB="25400" anchor="ctr">
@@ -3842,18 +3722,93 @@
                     <a:lstStyle/>
                     <a:p>
                       <a:pPr algn="l">
-                        <a:defRPr sz="1050"/>
+                        <a:defRPr sz="950"/>
                       </a:pPr>
                       <a:r>
-                        <a:rPr sz="1050" b="1">
+                        <a:rPr sz="950" b="0">
                           <a:solidFill>
                             <a:srgbClr val="11181C"/>
                           </a:solidFill>
                           <a:latin typeface="Arial"/>
                         </a:rPr>
-                        <a:t>Two leaders, one per class</a:t>
+                        <a:t>Triatra has no crane brand since HYVA stopped. Medium + Heavy = 41% of units, 64% of value (2023 – 2026). Heavy units 12 → 17 → 35 (2023 – 2025).</a:t>
                       </a:r>
-                      <a:endParaRPr sz="1050"/>
+                      <a:endParaRPr sz="950"/>
+                    </a:p>
+                  </a:txBody>
+                  <a:tcPr marL="50800" marR="50800" marT="25400" marB="25400" anchor="ctr">
+                    <a:lnL w="9525">
+                      <a:solidFill>
+                        <a:srgbClr val="E6E8EB"/>
+                      </a:solidFill>
+                    </a:lnL>
+                    <a:lnR w="9525">
+                      <a:solidFill>
+                        <a:srgbClr val="E6E8EB"/>
+                      </a:solidFill>
+                    </a:lnR>
+                    <a:lnT w="9525">
+                      <a:solidFill>
+                        <a:srgbClr val="E6E8EB"/>
+                      </a:solidFill>
+                    </a:lnT>
+                    <a:lnB w="9525">
+                      <a:solidFill>
+                        <a:srgbClr val="E6E8EB"/>
+                      </a:solidFill>
+                    </a:lnB>
+                    <a:noFill/>
+                  </a:tcPr>
+                </a:tc>
+              </a:tr>
+              <a:tr h="423862">
+                <a:tc vMerge="1">
+                  <a:txBody>
+                    <a:bodyPr/>
+                    <a:lstStyle/>
+                    <a:p/>
+                  </a:txBody>
+                  <a:tcPr>
+                    <a:lnL w="9525">
+                      <a:solidFill>
+                        <a:srgbClr val="E6E8EB"/>
+                      </a:solidFill>
+                    </a:lnL>
+                    <a:lnR w="9525">
+                      <a:solidFill>
+                        <a:srgbClr val="E6E8EB"/>
+                      </a:solidFill>
+                    </a:lnR>
+                    <a:lnT w="9525">
+                      <a:solidFill>
+                        <a:srgbClr val="E6E8EB"/>
+                      </a:solidFill>
+                    </a:lnT>
+                    <a:lnB w="9525">
+                      <a:solidFill>
+                        <a:srgbClr val="E6E8EB"/>
+                      </a:solidFill>
+                    </a:lnB>
+                  </a:tcPr>
+                </a:tc>
+                <a:tc>
+                  <a:txBody>
+                    <a:bodyPr wrap="square"/>
+                    <a:lstStyle/>
+                    <a:p>
+                      <a:pPr algn="l">
+                        <a:defRPr sz="1000"/>
+                      </a:pPr>
+                      <a:r>
+                        <a:rPr sz="1000" b="1">
+                          <a:solidFill>
+                            <a:srgbClr val="11181C"/>
+                          </a:solidFill>
+                          <a:latin typeface="Arial"/>
+                        </a:rPr>
+                        <a:t>Competitor</a:t>
+                      </a:r>
+                      <a:endParaRPr sz="1000"/>
                     </a:p>
                   </a:txBody>
                   <a:tcPr marL="50800" marR="50800" marT="25400" marB="25400" anchor="ctr">
@@ -3889,90 +3844,15 @@
                         <a:defRPr sz="1000"/>
                       </a:pPr>
                       <a:r>
-                        <a:rPr sz="1000" b="0">
+                        <a:rPr sz="1000" b="1">
                           <a:solidFill>
                             <a:srgbClr val="11181C"/>
                           </a:solidFill>
                           <a:latin typeface="Arial"/>
                         </a:rPr>
-                        <a:t>Medium: Sany Palfinger, 38% of value. Heavy: Palfinger, 66% of value; PK 53002 alone sold 39 of 65 units (2023 – 2026).</a:t>
+                        <a:t>Two leaders, one per class</a:t>
                       </a:r>
                       <a:endParaRPr sz="1000"/>
-                    </a:p>
-                  </a:txBody>
-                  <a:tcPr marL="50800" marR="50800" marT="25400" marB="25400" anchor="ctr">
-                    <a:lnL w="9525">
-                      <a:solidFill>
-                        <a:srgbClr val="E6E8EB"/>
-                      </a:solidFill>
-                    </a:lnL>
-                    <a:lnR w="9525">
-                      <a:solidFill>
-                        <a:srgbClr val="E6E8EB"/>
-                      </a:solidFill>
-                    </a:lnR>
-                    <a:lnT w="9525">
-                      <a:solidFill>
-                        <a:srgbClr val="E6E8EB"/>
-                      </a:solidFill>
-                    </a:lnT>
-                    <a:lnB w="9525">
-                      <a:solidFill>
-                        <a:srgbClr val="E6E8EB"/>
-                      </a:solidFill>
-                    </a:lnB>
-                    <a:noFill/>
-                  </a:tcPr>
-                </a:tc>
-              </a:tr>
-              <a:tr h="666750">
-                <a:tc vMerge="1">
-                  <a:txBody>
-                    <a:bodyPr/>
-                    <a:lstStyle/>
-                    <a:p/>
-                  </a:txBody>
-                  <a:tcPr>
-                    <a:lnL w="9525">
-                      <a:solidFill>
-                        <a:srgbClr val="E6E8EB"/>
-                      </a:solidFill>
-                    </a:lnL>
-                    <a:lnR w="9525">
-                      <a:solidFill>
-                        <a:srgbClr val="E6E8EB"/>
-                      </a:solidFill>
-                    </a:lnR>
-                    <a:lnT w="9525">
-                      <a:solidFill>
-                        <a:srgbClr val="E6E8EB"/>
-                      </a:solidFill>
-                    </a:lnT>
-                    <a:lnB w="9525">
-                      <a:solidFill>
-                        <a:srgbClr val="E6E8EB"/>
-                      </a:solidFill>
-                    </a:lnB>
-                  </a:tcPr>
-                </a:tc>
-                <a:tc>
-                  <a:txBody>
-                    <a:bodyPr wrap="square"/>
-                    <a:lstStyle/>
-                    <a:p>
-                      <a:pPr algn="l">
-                        <a:defRPr sz="1050"/>
-                      </a:pPr>
-                      <a:r>
-                        <a:rPr sz="1050" b="1">
-                          <a:solidFill>
-                            <a:srgbClr val="11181C"/>
-                          </a:solidFill>
-                          <a:latin typeface="Arial"/>
-                        </a:rPr>
-                        <a:t>Customer</a:t>
-                      </a:r>
-                      <a:endParaRPr sz="1050"/>
                     </a:p>
                   </a:txBody>
                   <a:tcPr marL="50800" marR="50800" marT="25400" marB="25400" anchor="ctr">
@@ -4005,18 +3885,93 @@
                     <a:lstStyle/>
                     <a:p>
                       <a:pPr algn="l">
-                        <a:defRPr sz="1050"/>
+                        <a:defRPr sz="950"/>
                       </a:pPr>
                       <a:r>
-                        <a:rPr sz="1050" b="1">
+                        <a:rPr sz="950" b="0">
                           <a:solidFill>
                             <a:srgbClr val="11181C"/>
                           </a:solidFill>
                           <a:latin typeface="Arial"/>
                         </a:rPr>
-                        <a:t>Medium buys on price, Heavy buys on quality</a:t>
+                        <a:t>Medium: Sany Palfinger, 38% of value. Heavy: Palfinger, 66% of value; PK 53002 alone sold 39 of 65 units (2023 – 2026).</a:t>
                       </a:r>
-                      <a:endParaRPr sz="1050"/>
+                      <a:endParaRPr sz="950"/>
+                    </a:p>
+                  </a:txBody>
+                  <a:tcPr marL="50800" marR="50800" marT="25400" marB="25400" anchor="ctr">
+                    <a:lnL w="9525">
+                      <a:solidFill>
+                        <a:srgbClr val="E6E8EB"/>
+                      </a:solidFill>
+                    </a:lnL>
+                    <a:lnR w="9525">
+                      <a:solidFill>
+                        <a:srgbClr val="E6E8EB"/>
+                      </a:solidFill>
+                    </a:lnR>
+                    <a:lnT w="9525">
+                      <a:solidFill>
+                        <a:srgbClr val="E6E8EB"/>
+                      </a:solidFill>
+                    </a:lnT>
+                    <a:lnB w="9525">
+                      <a:solidFill>
+                        <a:srgbClr val="E6E8EB"/>
+                      </a:solidFill>
+                    </a:lnB>
+                    <a:noFill/>
+                  </a:tcPr>
+                </a:tc>
+              </a:tr>
+              <a:tr h="423862">
+                <a:tc vMerge="1">
+                  <a:txBody>
+                    <a:bodyPr/>
+                    <a:lstStyle/>
+                    <a:p/>
+                  </a:txBody>
+                  <a:tcPr>
+                    <a:lnL w="9525">
+                      <a:solidFill>
+                        <a:srgbClr val="E6E8EB"/>
+                      </a:solidFill>
+                    </a:lnL>
+                    <a:lnR w="9525">
+                      <a:solidFill>
+                        <a:srgbClr val="E6E8EB"/>
+                      </a:solidFill>
+                    </a:lnR>
+                    <a:lnT w="9525">
+                      <a:solidFill>
+                        <a:srgbClr val="E6E8EB"/>
+                      </a:solidFill>
+                    </a:lnT>
+                    <a:lnB w="9525">
+                      <a:solidFill>
+                        <a:srgbClr val="E6E8EB"/>
+                      </a:solidFill>
+                    </a:lnB>
+                  </a:tcPr>
+                </a:tc>
+                <a:tc>
+                  <a:txBody>
+                    <a:bodyPr wrap="square"/>
+                    <a:lstStyle/>
+                    <a:p>
+                      <a:pPr algn="l">
+                        <a:defRPr sz="1000"/>
+                      </a:pPr>
+                      <a:r>
+                        <a:rPr sz="1000" b="1">
+                          <a:solidFill>
+                            <a:srgbClr val="11181C"/>
+                          </a:solidFill>
+                          <a:latin typeface="Arial"/>
+                        </a:rPr>
+                        <a:t>Customer</a:t>
+                      </a:r>
+                      <a:endParaRPr sz="1000"/>
                     </a:p>
                   </a:txBody>
                   <a:tcPr marL="50800" marR="50800" marT="25400" marB="25400" anchor="ctr">
@@ -4052,7 +4007,51 @@
                         <a:defRPr sz="1000"/>
                       </a:pPr>
                       <a:r>
-                        <a:rPr sz="1000" b="0">
+                        <a:rPr sz="1000" b="1">
+                          <a:solidFill>
+                            <a:srgbClr val="11181C"/>
+                          </a:solidFill>
+                          <a:latin typeface="Arial"/>
+                        </a:rPr>
+                        <a:t>Medium buys on price, Heavy buys on quality</a:t>
+                      </a:r>
+                      <a:endParaRPr sz="1000"/>
+                    </a:p>
+                  </a:txBody>
+                  <a:tcPr marL="50800" marR="50800" marT="25400" marB="25400" anchor="ctr">
+                    <a:lnL w="9525">
+                      <a:solidFill>
+                        <a:srgbClr val="E6E8EB"/>
+                      </a:solidFill>
+                    </a:lnL>
+                    <a:lnR w="9525">
+                      <a:solidFill>
+                        <a:srgbClr val="E6E8EB"/>
+                      </a:solidFill>
+                    </a:lnR>
+                    <a:lnT w="9525">
+                      <a:solidFill>
+                        <a:srgbClr val="E6E8EB"/>
+                      </a:solidFill>
+                    </a:lnT>
+                    <a:lnB w="9525">
+                      <a:solidFill>
+                        <a:srgbClr val="E6E8EB"/>
+                      </a:solidFill>
+                    </a:lnB>
+                    <a:noFill/>
+                  </a:tcPr>
+                </a:tc>
+                <a:tc>
+                  <a:txBody>
+                    <a:bodyPr wrap="square"/>
+                    <a:lstStyle/>
+                    <a:p>
+                      <a:pPr algn="l">
+                        <a:defRPr sz="950"/>
+                      </a:pPr>
+                      <a:r>
+                        <a:rPr sz="950" b="0">
                           <a:solidFill>
                             <a:srgbClr val="11181C"/>
                           </a:solidFill>
@@ -4060,7 +4059,7 @@
                         </a:rPr>
                         <a:t>China brands take 73% of Medium value; European brands take 85% of Heavy value. 88% go on trucks ≥ 24 t GVW (mining, construction).</a:t>
                       </a:r>
-                      <a:endParaRPr sz="1000"/>
+                      <a:endParaRPr sz="950"/>
                     </a:p>
                   </a:txBody>
                   <a:tcPr marL="50800" marR="50800" marT="25400" marB="25400" anchor="ctr">
@@ -4088,7 +4087,7 @@
                   </a:tcPr>
                 </a:tc>
               </a:tr>
-              <a:tr h="666750">
+              <a:tr h="423862">
                 <a:tc vMerge="1">
                   <a:txBody>
                     <a:bodyPr/>
@@ -4124,10 +4123,10 @@
                     <a:lstStyle/>
                     <a:p>
                       <a:pPr algn="l">
-                        <a:defRPr sz="1050"/>
+                        <a:defRPr sz="1000"/>
                       </a:pPr>
                       <a:r>
-                        <a:rPr sz="1050" b="1">
+                        <a:rPr sz="1000" b="1">
                           <a:solidFill>
                             <a:srgbClr val="11181C"/>
                           </a:solidFill>
@@ -4135,53 +4134,7 @@
                         </a:rPr>
                         <a:t>Company</a:t>
                       </a:r>
-                      <a:endParaRPr sz="1050"/>
-                    </a:p>
-                  </a:txBody>
-                  <a:tcPr marL="50800" marR="50800" marT="25400" marB="25400" anchor="ctr">
-                    <a:lnL w="9525">
-                      <a:solidFill>
-                        <a:srgbClr val="E6E8EB"/>
-                      </a:solidFill>
-                    </a:lnL>
-                    <a:lnR w="9525">
-                      <a:solidFill>
-                        <a:srgbClr val="E6E8EB"/>
-                      </a:solidFill>
-                    </a:lnR>
-                    <a:lnT w="9525">
-                      <a:solidFill>
-                        <a:srgbClr val="E6E8EB"/>
-                      </a:solidFill>
-                    </a:lnT>
-                    <a:lnB w="9525">
-                      <a:solidFill>
-                        <a:srgbClr val="E6E8EB"/>
-                      </a:solidFill>
-                    </a:lnB>
-                    <a:solidFill>
-                      <a:srgbClr val="E1F9EC"/>
-                    </a:solidFill>
-                  </a:tcPr>
-                </a:tc>
-                <a:tc>
-                  <a:txBody>
-                    <a:bodyPr wrap="square"/>
-                    <a:lstStyle/>
-                    <a:p>
-                      <a:pPr algn="l">
-                        <a:defRPr sz="1050"/>
-                      </a:pPr>
-                      <a:r>
-                        <a:rPr sz="1050" b="1">
-                          <a:solidFill>
-                            <a:srgbClr val="11181C"/>
-                          </a:solidFill>
-                          <a:latin typeface="Arial"/>
-                        </a:rPr>
-                        <a:t>Partner two brands to serve both buyers</a:t>
-                      </a:r>
-                      <a:endParaRPr sz="1050"/>
+                      <a:endParaRPr sz="1000"/>
                     </a:p>
                   </a:txBody>
                   <a:tcPr marL="50800" marR="50800" marT="25400" marB="25400" anchor="ctr">
@@ -4219,7 +4172,53 @@
                         <a:defRPr sz="1000"/>
                       </a:pPr>
                       <a:r>
-                        <a:rPr sz="1000" b="0">
+                        <a:rPr sz="1000" b="1">
+                          <a:solidFill>
+                            <a:srgbClr val="11181C"/>
+                          </a:solidFill>
+                          <a:latin typeface="Arial"/>
+                        </a:rPr>
+                        <a:t>Partner two brands to serve both buyers</a:t>
+                      </a:r>
+                      <a:endParaRPr sz="1000"/>
+                    </a:p>
+                  </a:txBody>
+                  <a:tcPr marL="50800" marR="50800" marT="25400" marB="25400" anchor="ctr">
+                    <a:lnL w="9525">
+                      <a:solidFill>
+                        <a:srgbClr val="E6E8EB"/>
+                      </a:solidFill>
+                    </a:lnL>
+                    <a:lnR w="9525">
+                      <a:solidFill>
+                        <a:srgbClr val="E6E8EB"/>
+                      </a:solidFill>
+                    </a:lnR>
+                    <a:lnT w="9525">
+                      <a:solidFill>
+                        <a:srgbClr val="E6E8EB"/>
+                      </a:solidFill>
+                    </a:lnT>
+                    <a:lnB w="9525">
+                      <a:solidFill>
+                        <a:srgbClr val="E6E8EB"/>
+                      </a:solidFill>
+                    </a:lnB>
+                    <a:solidFill>
+                      <a:srgbClr val="E1F9EC"/>
+                    </a:solidFill>
+                  </a:tcPr>
+                </a:tc>
+                <a:tc>
+                  <a:txBody>
+                    <a:bodyPr wrap="square"/>
+                    <a:lstStyle/>
+                    <a:p>
+                      <a:pPr algn="l">
+                        <a:defRPr sz="950"/>
+                      </a:pPr>
+                      <a:r>
+                        <a:rPr sz="950" b="0">
                           <a:solidFill>
                             <a:srgbClr val="11181C"/>
                           </a:solidFill>
@@ -4227,7 +4226,7 @@
                         </a:rPr>
                         <a:t>XCMG for price-oriented buyers. F.lli Ferrari for quality-oriented buyers.</a:t>
                       </a:r>
-                      <a:endParaRPr sz="1000"/>
+                      <a:endParaRPr sz="950"/>
                     </a:p>
                   </a:txBody>
                   <a:tcPr marL="50800" marR="50800" marT="25400" marB="25400" anchor="ctr">
@@ -4257,7 +4256,7 @@
                   </a:tcPr>
                 </a:tc>
               </a:tr>
-              <a:tr h="666750">
+              <a:tr h="423862">
                 <a:tc rowSpan="3">
                   <a:txBody>
                     <a:bodyPr wrap="square"/>
@@ -4308,10 +4307,10 @@
                     <a:lstStyle/>
                     <a:p>
                       <a:pPr algn="l">
-                        <a:defRPr sz="1050"/>
+                        <a:defRPr sz="1000"/>
                       </a:pPr>
                       <a:r>
-                        <a:rPr sz="1050" b="1">
+                        <a:rPr sz="1000" b="1">
                           <a:solidFill>
                             <a:srgbClr val="11181C"/>
                           </a:solidFill>
@@ -4319,51 +4318,7 @@
                         </a:rPr>
                         <a:t>Segmentation</a:t>
                       </a:r>
-                      <a:endParaRPr sz="1050"/>
-                    </a:p>
-                  </a:txBody>
-                  <a:tcPr marL="50800" marR="50800" marT="25400" marB="25400" anchor="ctr">
-                    <a:lnL w="9525">
-                      <a:solidFill>
-                        <a:srgbClr val="E6E8EB"/>
-                      </a:solidFill>
-                    </a:lnL>
-                    <a:lnR w="9525">
-                      <a:solidFill>
-                        <a:srgbClr val="E6E8EB"/>
-                      </a:solidFill>
-                    </a:lnR>
-                    <a:lnT w="9525">
-                      <a:solidFill>
-                        <a:srgbClr val="E6E8EB"/>
-                      </a:solidFill>
-                    </a:lnT>
-                    <a:lnB w="9525">
-                      <a:solidFill>
-                        <a:srgbClr val="E6E8EB"/>
-                      </a:solidFill>
-                    </a:lnB>
-                    <a:noFill/>
-                  </a:tcPr>
-                </a:tc>
-                <a:tc>
-                  <a:txBody>
-                    <a:bodyPr wrap="square"/>
-                    <a:lstStyle/>
-                    <a:p>
-                      <a:pPr algn="l">
-                        <a:defRPr sz="1050"/>
-                      </a:pPr>
-                      <a:r>
-                        <a:rPr sz="1050" b="1">
-                          <a:solidFill>
-                            <a:srgbClr val="11181C"/>
-                          </a:solidFill>
-                          <a:latin typeface="Arial"/>
-                        </a:rPr>
-                        <a:t>Two classes, ten 5-tm tiers</a:t>
-                      </a:r>
-                      <a:endParaRPr sz="1050"/>
+                      <a:endParaRPr sz="1000"/>
                     </a:p>
                   </a:txBody>
                   <a:tcPr marL="50800" marR="50800" marT="25400" marB="25400" anchor="ctr">
@@ -4399,974 +4354,15 @@
                         <a:defRPr sz="1000"/>
                       </a:pPr>
                       <a:r>
-                        <a:rPr sz="1000" b="0">
+                        <a:rPr sz="1000" b="1">
                           <a:solidFill>
                             <a:srgbClr val="11181C"/>
                           </a:solidFill>
                           <a:latin typeface="Arial"/>
                         </a:rPr>
-                        <a:t>Medium 25 – 45 tm: 196 units, Rp 156 M. Heavy &gt; 45 tm: 65 units, Rp 115 M.</a:t>
+                        <a:t>Two classes, ten 5-tm tiers</a:t>
                       </a:r>
                       <a:endParaRPr sz="1000"/>
-                    </a:p>
-                  </a:txBody>
-                  <a:tcPr marL="50800" marR="50800" marT="25400" marB="25400" anchor="ctr">
-                    <a:lnL w="9525">
-                      <a:solidFill>
-                        <a:srgbClr val="E6E8EB"/>
-                      </a:solidFill>
-                    </a:lnL>
-                    <a:lnR w="9525">
-                      <a:solidFill>
-                        <a:srgbClr val="E6E8EB"/>
-                      </a:solidFill>
-                    </a:lnR>
-                    <a:lnT w="9525">
-                      <a:solidFill>
-                        <a:srgbClr val="E6E8EB"/>
-                      </a:solidFill>
-                    </a:lnT>
-                    <a:lnB w="9525">
-                      <a:solidFill>
-                        <a:srgbClr val="E6E8EB"/>
-                      </a:solidFill>
-                    </a:lnB>
-                    <a:noFill/>
-                  </a:tcPr>
-                </a:tc>
-              </a:tr>
-              <a:tr h="666750">
-                <a:tc vMerge="1">
-                  <a:txBody>
-                    <a:bodyPr/>
-                    <a:lstStyle/>
-                    <a:p/>
-                  </a:txBody>
-                  <a:tcPr>
-                    <a:lnL w="9525">
-                      <a:solidFill>
-                        <a:srgbClr val="E6E8EB"/>
-                      </a:solidFill>
-                    </a:lnL>
-                    <a:lnR w="9525">
-                      <a:solidFill>
-                        <a:srgbClr val="E6E8EB"/>
-                      </a:solidFill>
-                    </a:lnR>
-                    <a:lnT w="9525">
-                      <a:solidFill>
-                        <a:srgbClr val="E6E8EB"/>
-                      </a:solidFill>
-                    </a:lnT>
-                    <a:lnB w="9525">
-                      <a:solidFill>
-                        <a:srgbClr val="E6E8EB"/>
-                      </a:solidFill>
-                    </a:lnB>
-                  </a:tcPr>
-                </a:tc>
-                <a:tc>
-                  <a:txBody>
-                    <a:bodyPr wrap="square"/>
-                    <a:lstStyle/>
-                    <a:p>
-                      <a:pPr algn="l">
-                        <a:defRPr sz="1050"/>
-                      </a:pPr>
-                      <a:r>
-                        <a:rPr sz="1050" b="1">
-                          <a:solidFill>
-                            <a:srgbClr val="11181C"/>
-                          </a:solidFill>
-                          <a:latin typeface="Arial"/>
-                        </a:rPr>
-                        <a:t>Targeting</a:t>
-                      </a:r>
-                      <a:endParaRPr sz="1050"/>
-                    </a:p>
-                  </a:txBody>
-                  <a:tcPr marL="50800" marR="50800" marT="25400" marB="25400" anchor="ctr">
-                    <a:lnL w="9525">
-                      <a:solidFill>
-                        <a:srgbClr val="E6E8EB"/>
-                      </a:solidFill>
-                    </a:lnL>
-                    <a:lnR w="9525">
-                      <a:solidFill>
-                        <a:srgbClr val="E6E8EB"/>
-                      </a:solidFill>
-                    </a:lnR>
-                    <a:lnT w="9525">
-                      <a:solidFill>
-                        <a:srgbClr val="E6E8EB"/>
-                      </a:solidFill>
-                    </a:lnT>
-                    <a:lnB w="9525">
-                      <a:solidFill>
-                        <a:srgbClr val="E6E8EB"/>
-                      </a:solidFill>
-                    </a:lnB>
-                    <a:noFill/>
-                  </a:tcPr>
-                </a:tc>
-                <a:tc>
-                  <a:txBody>
-                    <a:bodyPr wrap="square"/>
-                    <a:lstStyle/>
-                    <a:p>
-                      <a:pPr algn="l">
-                        <a:defRPr sz="1050"/>
-                      </a:pPr>
-                      <a:r>
-                        <a:rPr sz="1050" b="1">
-                          <a:solidFill>
-                            <a:srgbClr val="11181C"/>
-                          </a:solidFill>
-                          <a:latin typeface="Arial"/>
-                        </a:rPr>
-                        <a:t>Take share from the Top 1 model in each tier</a:t>
-                      </a:r>
-                      <a:endParaRPr sz="1050"/>
-                    </a:p>
-                  </a:txBody>
-                  <a:tcPr marL="50800" marR="50800" marT="25400" marB="25400" anchor="ctr">
-                    <a:lnL w="9525">
-                      <a:solidFill>
-                        <a:srgbClr val="E6E8EB"/>
-                      </a:solidFill>
-                    </a:lnL>
-                    <a:lnR w="9525">
-                      <a:solidFill>
-                        <a:srgbClr val="E6E8EB"/>
-                      </a:solidFill>
-                    </a:lnR>
-                    <a:lnT w="9525">
-                      <a:solidFill>
-                        <a:srgbClr val="E6E8EB"/>
-                      </a:solidFill>
-                    </a:lnT>
-                    <a:lnB w="9525">
-                      <a:solidFill>
-                        <a:srgbClr val="E6E8EB"/>
-                      </a:solidFill>
-                    </a:lnB>
-                    <a:noFill/>
-                  </a:tcPr>
-                </a:tc>
-                <a:tc>
-                  <a:txBody>
-                    <a:bodyPr wrap="square"/>
-                    <a:lstStyle/>
-                    <a:p>
-                      <a:pPr algn="l">
-                        <a:defRPr sz="1000"/>
-                      </a:pPr>
-                      <a:r>
-                        <a:rPr sz="1000" b="0">
-                          <a:solidFill>
-                            <a:srgbClr val="11181C"/>
-                          </a:solidFill>
-                          <a:latin typeface="Arial"/>
-                        </a:rPr>
-                        <a:t>Medium: Sany Palfinger SPK32080, SPK36080, SPK42502. Heavy: Palfinger PK 53002, PK 76002, PK 88002.</a:t>
-                      </a:r>
-                      <a:endParaRPr sz="1000"/>
-                    </a:p>
-                  </a:txBody>
-                  <a:tcPr marL="50800" marR="50800" marT="25400" marB="25400" anchor="ctr">
-                    <a:lnL w="9525">
-                      <a:solidFill>
-                        <a:srgbClr val="E6E8EB"/>
-                      </a:solidFill>
-                    </a:lnL>
-                    <a:lnR w="9525">
-                      <a:solidFill>
-                        <a:srgbClr val="E6E8EB"/>
-                      </a:solidFill>
-                    </a:lnR>
-                    <a:lnT w="9525">
-                      <a:solidFill>
-                        <a:srgbClr val="E6E8EB"/>
-                      </a:solidFill>
-                    </a:lnT>
-                    <a:lnB w="9525">
-                      <a:solidFill>
-                        <a:srgbClr val="E6E8EB"/>
-                      </a:solidFill>
-                    </a:lnB>
-                    <a:noFill/>
-                  </a:tcPr>
-                </a:tc>
-              </a:tr>
-              <a:tr h="666750">
-                <a:tc vMerge="1">
-                  <a:txBody>
-                    <a:bodyPr/>
-                    <a:lstStyle/>
-                    <a:p/>
-                  </a:txBody>
-                  <a:tcPr>
-                    <a:lnL w="9525">
-                      <a:solidFill>
-                        <a:srgbClr val="E6E8EB"/>
-                      </a:solidFill>
-                    </a:lnL>
-                    <a:lnR w="9525">
-                      <a:solidFill>
-                        <a:srgbClr val="E6E8EB"/>
-                      </a:solidFill>
-                    </a:lnR>
-                    <a:lnT w="9525">
-                      <a:solidFill>
-                        <a:srgbClr val="E6E8EB"/>
-                      </a:solidFill>
-                    </a:lnT>
-                    <a:lnB w="9525">
-                      <a:solidFill>
-                        <a:srgbClr val="E6E8EB"/>
-                      </a:solidFill>
-                    </a:lnB>
-                  </a:tcPr>
-                </a:tc>
-                <a:tc>
-                  <a:txBody>
-                    <a:bodyPr wrap="square"/>
-                    <a:lstStyle/>
-                    <a:p>
-                      <a:pPr algn="l">
-                        <a:defRPr sz="1050"/>
-                      </a:pPr>
-                      <a:r>
-                        <a:rPr sz="1050" b="1">
-                          <a:solidFill>
-                            <a:srgbClr val="11181C"/>
-                          </a:solidFill>
-                          <a:latin typeface="Arial"/>
-                        </a:rPr>
-                        <a:t>Positioning</a:t>
-                      </a:r>
-                      <a:endParaRPr sz="1050"/>
-                    </a:p>
-                  </a:txBody>
-                  <a:tcPr marL="50800" marR="50800" marT="25400" marB="25400" anchor="ctr">
-                    <a:lnL w="9525">
-                      <a:solidFill>
-                        <a:srgbClr val="E6E8EB"/>
-                      </a:solidFill>
-                    </a:lnL>
-                    <a:lnR w="9525">
-                      <a:solidFill>
-                        <a:srgbClr val="E6E8EB"/>
-                      </a:solidFill>
-                    </a:lnR>
-                    <a:lnT w="9525">
-                      <a:solidFill>
-                        <a:srgbClr val="E6E8EB"/>
-                      </a:solidFill>
-                    </a:lnT>
-                    <a:lnB w="9525">
-                      <a:solidFill>
-                        <a:srgbClr val="E6E8EB"/>
-                      </a:solidFill>
-                    </a:lnB>
-                    <a:noFill/>
-                  </a:tcPr>
-                </a:tc>
-                <a:tc>
-                  <a:txBody>
-                    <a:bodyPr wrap="square"/>
-                    <a:lstStyle/>
-                    <a:p>
-                      <a:pPr algn="l">
-                        <a:defRPr sz="1050"/>
-                      </a:pPr>
-                      <a:r>
-                        <a:rPr sz="1050" b="1">
-                          <a:solidFill>
-                            <a:srgbClr val="11181C"/>
-                          </a:solidFill>
-                          <a:latin typeface="Arial"/>
-                        </a:rPr>
-                        <a:t>Two clear promises</a:t>
-                      </a:r>
-                      <a:endParaRPr sz="1050"/>
-                    </a:p>
-                  </a:txBody>
-                  <a:tcPr marL="50800" marR="50800" marT="25400" marB="25400" anchor="ctr">
-                    <a:lnL w="9525">
-                      <a:solidFill>
-                        <a:srgbClr val="E6E8EB"/>
-                      </a:solidFill>
-                    </a:lnL>
-                    <a:lnR w="9525">
-                      <a:solidFill>
-                        <a:srgbClr val="E6E8EB"/>
-                      </a:solidFill>
-                    </a:lnR>
-                    <a:lnT w="9525">
-                      <a:solidFill>
-                        <a:srgbClr val="E6E8EB"/>
-                      </a:solidFill>
-                    </a:lnT>
-                    <a:lnB w="9525">
-                      <a:solidFill>
-                        <a:srgbClr val="E6E8EB"/>
-                      </a:solidFill>
-                    </a:lnB>
-                    <a:noFill/>
-                  </a:tcPr>
-                </a:tc>
-                <a:tc>
-                  <a:txBody>
-                    <a:bodyPr wrap="square"/>
-                    <a:lstStyle/>
-                    <a:p>
-                      <a:pPr algn="l">
-                        <a:defRPr sz="1000"/>
-                      </a:pPr>
-                      <a:r>
-                        <a:rPr sz="1000" b="0">
-                          <a:solidFill>
-                            <a:srgbClr val="11181C"/>
-                          </a:solidFill>
-                          <a:latin typeface="Arial"/>
-                        </a:rPr>
-                        <a:t>XCMG: same capacity, lower price (SQZ365.4 −9% vs SPK36080). Ferrari: European features, cheaper where it wins (−23% at 25 – 30 tm, −32% at 45 – 50 tm) and faster delivery from China stock (~14 weeks).</a:t>
-                      </a:r>
-                      <a:endParaRPr sz="1000"/>
-                    </a:p>
-                  </a:txBody>
-                  <a:tcPr marL="50800" marR="50800" marT="25400" marB="25400" anchor="ctr">
-                    <a:lnL w="9525">
-                      <a:solidFill>
-                        <a:srgbClr val="E6E8EB"/>
-                      </a:solidFill>
-                    </a:lnL>
-                    <a:lnR w="9525">
-                      <a:solidFill>
-                        <a:srgbClr val="E6E8EB"/>
-                      </a:solidFill>
-                    </a:lnR>
-                    <a:lnT w="9525">
-                      <a:solidFill>
-                        <a:srgbClr val="E6E8EB"/>
-                      </a:solidFill>
-                    </a:lnT>
-                    <a:lnB w="9525">
-                      <a:solidFill>
-                        <a:srgbClr val="E6E8EB"/>
-                      </a:solidFill>
-                    </a:lnB>
-                    <a:noFill/>
-                  </a:tcPr>
-                </a:tc>
-              </a:tr>
-            </a:tbl>
-          </a:graphicData>
-        </a:graphic>
-      </p:graphicFrame>
-    </p:spTree>
-  </p:cSld>
-  <p:clrMapOvr>
-    <a:masterClrMapping/>
-  </p:clrMapOvr>
-</p:sld>
-</file>
-
-<file path=ppt/slides/slide9.xml><?xml version="1.0" encoding="utf-8"?>
-<p:sld xmlns:a="http://schemas.openxmlformats.org/drawingml/2006/main" xmlns:p="http://schemas.openxmlformats.org/presentationml/2006/main" xmlns:r="http://schemas.openxmlformats.org/officeDocument/2006/relationships">
-  <p:cSld>
-    <p:bg>
-      <p:bgPr>
-        <a:solidFill>
-          <a:srgbClr val="FFFFFF"/>
-        </a:solidFill>
-        <a:effectLst/>
-      </p:bgPr>
-    </p:bg>
-    <p:spTree>
-      <p:nvGrpSpPr>
-        <p:cNvPr id="1" name=""/>
-        <p:cNvGrpSpPr/>
-        <p:nvPr/>
-      </p:nvGrpSpPr>
-      <p:grpSpPr/>
-      <p:pic>
-        <p:nvPicPr>
-          <p:cNvPr id="2" name="Picture 1" descr="triatra_logo.png"/>
-          <p:cNvPicPr>
-            <a:picLocks noChangeAspect="1"/>
-          </p:cNvPicPr>
-          <p:nvPr/>
-        </p:nvPicPr>
-        <p:blipFill>
-          <a:blip r:embed="rId2"/>
-          <a:stretch>
-            <a:fillRect/>
-          </a:stretch>
-        </p:blipFill>
-        <p:spPr>
-          <a:xfrm>
-            <a:off x="533400" y="228600"/>
-            <a:ext cx="457034" cy="209550"/>
-          </a:xfrm>
-          <a:prstGeom prst="rect">
-            <a:avLst/>
-          </a:prstGeom>
-        </p:spPr>
-      </p:pic>
-      <p:sp>
-        <p:nvSpPr>
-          <p:cNvPr id="3" name="TextBox 2"/>
-          <p:cNvSpPr txBox="1"/>
-          <p:nvPr/>
-        </p:nvSpPr>
-        <p:spPr>
-          <a:xfrm>
-            <a:off x="6096000" y="276225"/>
-            <a:ext cx="5562600" cy="133350"/>
-          </a:xfrm>
-          <a:prstGeom prst="rect">
-            <a:avLst/>
-          </a:prstGeom>
-          <a:noFill/>
-        </p:spPr>
-        <p:txBody>
-          <a:bodyPr wrap="square" lIns="0" rIns="0" tIns="0" bIns="0" anchor="t">
-            <a:spAutoFit/>
-          </a:bodyPr>
-          <a:lstStyle/>
-          <a:p>
-            <a:pPr algn="r"/>
-            <a:r>
-              <a:rPr sz="750" b="0" i="0" spc="100">
-                <a:solidFill>
-                  <a:srgbClr val="697177"/>
-                </a:solidFill>
-                <a:latin typeface="Arial"/>
-              </a:rPr>
-              <a:t>NEDP 6-MONTH REVIEW  ·  4P · ACTION PLAN</a:t>
-            </a:r>
-          </a:p>
-        </p:txBody>
-      </p:sp>
-      <p:cxnSp>
-        <p:nvCxnSpPr>
-          <p:cNvPr id="4" name="Connector 3"/>
-          <p:cNvCxnSpPr/>
-          <p:nvPr/>
-        </p:nvCxnSpPr>
-        <p:spPr>
-          <a:xfrm>
-            <a:off x="533400" y="533400"/>
-            <a:ext cx="11125200" cy="0"/>
-          </a:xfrm>
-          <a:prstGeom prst="line">
-            <a:avLst/>
-          </a:prstGeom>
-          <a:ln w="9525">
-            <a:solidFill>
-              <a:srgbClr val="E6E8EB"/>
-            </a:solidFill>
-          </a:ln>
-        </p:spPr>
-      </p:cxnSp>
-      <p:sp>
-        <p:nvSpPr>
-          <p:cNvPr id="5" name="TextBox 4"/>
-          <p:cNvSpPr txBox="1"/>
-          <p:nvPr/>
-        </p:nvSpPr>
-        <p:spPr>
-          <a:xfrm>
-            <a:off x="533400" y="704850"/>
-            <a:ext cx="5715000" cy="133350"/>
-          </a:xfrm>
-          <a:prstGeom prst="rect">
-            <a:avLst/>
-          </a:prstGeom>
-          <a:noFill/>
-        </p:spPr>
-        <p:txBody>
-          <a:bodyPr wrap="square" lIns="0" rIns="0" tIns="0" bIns="0" anchor="t">
-            <a:spAutoFit/>
-          </a:bodyPr>
-          <a:lstStyle/>
-          <a:p>
-            <a:pPr algn="l"/>
-            <a:r>
-              <a:rPr sz="850" b="1" i="0" spc="150">
-                <a:solidFill>
-                  <a:srgbClr val="697177"/>
-                </a:solidFill>
-                <a:latin typeface="Arial"/>
-              </a:rPr>
-              <a:t>4P · ACTION PLAN</a:t>
-            </a:r>
-          </a:p>
-        </p:txBody>
-      </p:sp>
-      <p:sp>
-        <p:nvSpPr>
-          <p:cNvPr id="6" name="TextBox 5"/>
-          <p:cNvSpPr txBox="1"/>
-          <p:nvPr/>
-        </p:nvSpPr>
-        <p:spPr>
-          <a:xfrm>
-            <a:off x="533400" y="857250"/>
-            <a:ext cx="11125200" cy="381000"/>
-          </a:xfrm>
-          <a:prstGeom prst="rect">
-            <a:avLst/>
-          </a:prstGeom>
-          <a:noFill/>
-        </p:spPr>
-        <p:txBody>
-          <a:bodyPr wrap="square" lIns="0" rIns="0" tIns="0" bIns="0" anchor="t">
-            <a:spAutoFit/>
-          </a:bodyPr>
-          <a:lstStyle/>
-          <a:p>
-            <a:pPr algn="l"/>
-            <a:r>
-              <a:rPr sz="2100" b="0" i="0">
-                <a:solidFill>
-                  <a:srgbClr val="11181C"/>
-                </a:solidFill>
-                <a:latin typeface="Georgia"/>
-              </a:rPr>
-              <a:t>Four actions to </a:t>
-            </a:r>
-            <a:r>
-              <a:rPr sz="2100" b="0" i="1">
-                <a:solidFill>
-                  <a:srgbClr val="076932"/>
-                </a:solidFill>
-                <a:latin typeface="Georgia"/>
-              </a:rPr>
-              <a:t>win the first sale</a:t>
-            </a:r>
-            <a:r>
-              <a:rPr sz="2100" b="0" i="0">
-                <a:solidFill>
-                  <a:srgbClr val="11181C"/>
-                </a:solidFill>
-                <a:latin typeface="Georgia"/>
-              </a:rPr>
-              <a:t>: features, price, stock and package</a:t>
-            </a:r>
-          </a:p>
-        </p:txBody>
-      </p:sp>
-      <p:cxnSp>
-        <p:nvCxnSpPr>
-          <p:cNvPr id="7" name="Connector 6"/>
-          <p:cNvCxnSpPr/>
-          <p:nvPr/>
-        </p:nvCxnSpPr>
-        <p:spPr>
-          <a:xfrm>
-            <a:off x="533400" y="6591300"/>
-            <a:ext cx="11125200" cy="0"/>
-          </a:xfrm>
-          <a:prstGeom prst="line">
-            <a:avLst/>
-          </a:prstGeom>
-          <a:ln w="9525">
-            <a:solidFill>
-              <a:srgbClr val="E6E8EB"/>
-            </a:solidFill>
-          </a:ln>
-        </p:spPr>
-      </p:cxnSp>
-      <p:sp>
-        <p:nvSpPr>
-          <p:cNvPr id="8" name="TextBox 7"/>
-          <p:cNvSpPr txBox="1"/>
-          <p:nvPr/>
-        </p:nvSpPr>
-        <p:spPr>
-          <a:xfrm>
-            <a:off x="533400" y="6648450"/>
-            <a:ext cx="5715000" cy="114300"/>
-          </a:xfrm>
-          <a:prstGeom prst="rect">
-            <a:avLst/>
-          </a:prstGeom>
-          <a:noFill/>
-        </p:spPr>
-        <p:txBody>
-          <a:bodyPr wrap="square" lIns="0" rIns="0" tIns="0" bIns="0" anchor="t">
-            <a:spAutoFit/>
-          </a:bodyPr>
-          <a:lstStyle/>
-          <a:p>
-            <a:pPr algn="l"/>
-            <a:r>
-              <a:rPr sz="700" b="1" i="0" spc="100">
-                <a:solidFill>
-                  <a:srgbClr val="889096"/>
-                </a:solidFill>
-                <a:latin typeface="Arial"/>
-              </a:rPr>
-              <a:t>NEDP MID YEAR REVIEW 2026  ·  TIBERIAS K. SIMU</a:t>
-            </a:r>
-          </a:p>
-        </p:txBody>
-      </p:sp>
-      <p:sp>
-        <p:nvSpPr>
-          <p:cNvPr id="9" name="TextBox 8"/>
-          <p:cNvSpPr txBox="1"/>
-          <p:nvPr/>
-        </p:nvSpPr>
-        <p:spPr>
-          <a:xfrm>
-            <a:off x="9753600" y="6648450"/>
-            <a:ext cx="1905000" cy="114300"/>
-          </a:xfrm>
-          <a:prstGeom prst="rect">
-            <a:avLst/>
-          </a:prstGeom>
-          <a:noFill/>
-        </p:spPr>
-        <p:txBody>
-          <a:bodyPr wrap="square" lIns="0" rIns="0" tIns="0" bIns="0" anchor="t">
-            <a:spAutoFit/>
-          </a:bodyPr>
-          <a:lstStyle/>
-          <a:p>
-            <a:pPr algn="r"/>
-            <a:r>
-              <a:rPr sz="700" b="1" i="0" spc="100">
-                <a:solidFill>
-                  <a:srgbClr val="889096"/>
-                </a:solidFill>
-                <a:latin typeface="Arial"/>
-              </a:rPr>
-              <a:t>09 / 19</a:t>
-            </a:r>
-          </a:p>
-        </p:txBody>
-      </p:sp>
-      <p:graphicFrame>
-        <p:nvGraphicFramePr>
-          <p:cNvPr id="10" name="Table 9"/>
-          <p:cNvGraphicFramePr>
-            <a:graphicFrameLocks noGrp="1"/>
-          </p:cNvGraphicFramePr>
-          <p:nvPr/>
-        </p:nvGraphicFramePr>
-        <p:xfrm>
-          <a:off x="533400" y="1504950"/>
-          <a:ext cx="11125200" cy="4533900"/>
-        </p:xfrm>
-        <a:graphic>
-          <a:graphicData uri="http://schemas.openxmlformats.org/drawingml/2006/table">
-            <a:tbl>
-              <a:tblPr firstRow="0" bandRow="0">
-                <a:tableStyleId>{5940675A-B579-460E-94D1-54222C63F5DA}</a:tableStyleId>
-              </a:tblPr>
-              <a:tblGrid>
-                <a:gridCol w="1047750"/>
-                <a:gridCol w="2476500"/>
-                <a:gridCol w="2190750"/>
-                <a:gridCol w="5410200"/>
-              </a:tblGrid>
-              <a:tr h="323850">
-                <a:tc>
-                  <a:txBody>
-                    <a:bodyPr wrap="square"/>
-                    <a:lstStyle/>
-                    <a:p>
-                      <a:pPr algn="l">
-                        <a:defRPr sz="900"/>
-                      </a:pPr>
-                      <a:r>
-                        <a:rPr sz="900" b="1">
-                          <a:solidFill>
-                            <a:srgbClr val="11181C"/>
-                          </a:solidFill>
-                          <a:latin typeface="Arial"/>
-                        </a:rPr>
-                        <a:t>4P</a:t>
-                      </a:r>
-                      <a:endParaRPr sz="900"/>
-                    </a:p>
-                  </a:txBody>
-                  <a:tcPr marL="50800" marR="50800" marT="25400" marB="25400" anchor="ctr">
-                    <a:lnL w="9525">
-                      <a:solidFill>
-                        <a:srgbClr val="D7DBDF"/>
-                      </a:solidFill>
-                    </a:lnL>
-                    <a:lnR w="9525">
-                      <a:solidFill>
-                        <a:srgbClr val="D7DBDF"/>
-                      </a:solidFill>
-                    </a:lnR>
-                    <a:lnT w="9525">
-                      <a:solidFill>
-                        <a:srgbClr val="D7DBDF"/>
-                      </a:solidFill>
-                    </a:lnT>
-                    <a:lnB w="9525">
-                      <a:solidFill>
-                        <a:srgbClr val="D7DBDF"/>
-                      </a:solidFill>
-                    </a:lnB>
-                    <a:solidFill>
-                      <a:srgbClr val="F0F2F4"/>
-                    </a:solidFill>
-                  </a:tcPr>
-                </a:tc>
-                <a:tc>
-                  <a:txBody>
-                    <a:bodyPr wrap="square"/>
-                    <a:lstStyle/>
-                    <a:p>
-                      <a:pPr algn="l">
-                        <a:defRPr sz="900"/>
-                      </a:pPr>
-                      <a:r>
-                        <a:rPr sz="900" b="1">
-                          <a:solidFill>
-                            <a:srgbClr val="11181C"/>
-                          </a:solidFill>
-                          <a:latin typeface="Arial"/>
-                        </a:rPr>
-                        <a:t>To do</a:t>
-                      </a:r>
-                      <a:endParaRPr sz="900"/>
-                    </a:p>
-                  </a:txBody>
-                  <a:tcPr marL="50800" marR="50800" marT="25400" marB="25400" anchor="ctr">
-                    <a:lnL w="9525">
-                      <a:solidFill>
-                        <a:srgbClr val="D7DBDF"/>
-                      </a:solidFill>
-                    </a:lnL>
-                    <a:lnR w="9525">
-                      <a:solidFill>
-                        <a:srgbClr val="D7DBDF"/>
-                      </a:solidFill>
-                    </a:lnR>
-                    <a:lnT w="9525">
-                      <a:solidFill>
-                        <a:srgbClr val="D7DBDF"/>
-                      </a:solidFill>
-                    </a:lnT>
-                    <a:lnB w="9525">
-                      <a:solidFill>
-                        <a:srgbClr val="D7DBDF"/>
-                      </a:solidFill>
-                    </a:lnB>
-                    <a:solidFill>
-                      <a:srgbClr val="F0F2F4"/>
-                    </a:solidFill>
-                  </a:tcPr>
-                </a:tc>
-                <a:tc>
-                  <a:txBody>
-                    <a:bodyPr wrap="square"/>
-                    <a:lstStyle/>
-                    <a:p>
-                      <a:pPr algn="l">
-                        <a:defRPr sz="900"/>
-                      </a:pPr>
-                      <a:r>
-                        <a:rPr sz="900" b="1">
-                          <a:solidFill>
-                            <a:srgbClr val="11181C"/>
-                          </a:solidFill>
-                          <a:latin typeface="Arial"/>
-                        </a:rPr>
-                        <a:t>Item</a:t>
-                      </a:r>
-                      <a:endParaRPr sz="900"/>
-                    </a:p>
-                  </a:txBody>
-                  <a:tcPr marL="50800" marR="50800" marT="25400" marB="25400" anchor="ctr">
-                    <a:lnL w="9525">
-                      <a:solidFill>
-                        <a:srgbClr val="D7DBDF"/>
-                      </a:solidFill>
-                    </a:lnL>
-                    <a:lnR w="9525">
-                      <a:solidFill>
-                        <a:srgbClr val="D7DBDF"/>
-                      </a:solidFill>
-                    </a:lnR>
-                    <a:lnT w="9525">
-                      <a:solidFill>
-                        <a:srgbClr val="D7DBDF"/>
-                      </a:solidFill>
-                    </a:lnT>
-                    <a:lnB w="9525">
-                      <a:solidFill>
-                        <a:srgbClr val="D7DBDF"/>
-                      </a:solidFill>
-                    </a:lnB>
-                    <a:solidFill>
-                      <a:srgbClr val="F0F2F4"/>
-                    </a:solidFill>
-                  </a:tcPr>
-                </a:tc>
-                <a:tc>
-                  <a:txBody>
-                    <a:bodyPr wrap="square"/>
-                    <a:lstStyle/>
-                    <a:p>
-                      <a:pPr algn="l">
-                        <a:defRPr sz="900"/>
-                      </a:pPr>
-                      <a:r>
-                        <a:rPr sz="900" b="1">
-                          <a:solidFill>
-                            <a:srgbClr val="11181C"/>
-                          </a:solidFill>
-                          <a:latin typeface="Arial"/>
-                        </a:rPr>
-                        <a:t>Detail</a:t>
-                      </a:r>
-                      <a:endParaRPr sz="900"/>
-                    </a:p>
-                  </a:txBody>
-                  <a:tcPr marL="50800" marR="50800" marT="25400" marB="25400" anchor="ctr">
-                    <a:lnL w="9525">
-                      <a:solidFill>
-                        <a:srgbClr val="D7DBDF"/>
-                      </a:solidFill>
-                    </a:lnL>
-                    <a:lnR w="9525">
-                      <a:solidFill>
-                        <a:srgbClr val="D7DBDF"/>
-                      </a:solidFill>
-                    </a:lnR>
-                    <a:lnT w="9525">
-                      <a:solidFill>
-                        <a:srgbClr val="D7DBDF"/>
-                      </a:solidFill>
-                    </a:lnT>
-                    <a:lnB w="9525">
-                      <a:solidFill>
-                        <a:srgbClr val="D7DBDF"/>
-                      </a:solidFill>
-                    </a:lnB>
-                    <a:solidFill>
-                      <a:srgbClr val="F0F2F4"/>
-                    </a:solidFill>
-                  </a:tcPr>
-                </a:tc>
-              </a:tr>
-              <a:tr h="323850">
-                <a:tc rowSpan="6">
-                  <a:txBody>
-                    <a:bodyPr wrap="square"/>
-                    <a:lstStyle/>
-                    <a:p>
-                      <a:pPr algn="l">
-                        <a:defRPr sz="1100"/>
-                      </a:pPr>
-                      <a:r>
-                        <a:rPr sz="1100" b="1">
-                          <a:solidFill>
-                            <a:srgbClr val="076932"/>
-                          </a:solidFill>
-                          <a:latin typeface="Arial"/>
-                        </a:rPr>
-                        <a:t>Product</a:t>
-                      </a:r>
-                      <a:endParaRPr sz="1100"/>
-                    </a:p>
-                  </a:txBody>
-                  <a:tcPr marL="50800" marR="50800" marT="25400" marB="25400" anchor="ctr">
-                    <a:lnL w="9525">
-                      <a:solidFill>
-                        <a:srgbClr val="E6E8EB"/>
-                      </a:solidFill>
-                    </a:lnL>
-                    <a:lnR w="9525">
-                      <a:solidFill>
-                        <a:srgbClr val="E6E8EB"/>
-                      </a:solidFill>
-                    </a:lnR>
-                    <a:lnT w="9525">
-                      <a:solidFill>
-                        <a:srgbClr val="E6E8EB"/>
-                      </a:solidFill>
-                    </a:lnT>
-                    <a:lnB w="9525">
-                      <a:solidFill>
-                        <a:srgbClr val="E6E8EB"/>
-                      </a:solidFill>
-                    </a:lnB>
-                    <a:noFill/>
-                  </a:tcPr>
-                </a:tc>
-                <a:tc rowSpan="6">
-                  <a:txBody>
-                    <a:bodyPr wrap="square"/>
-                    <a:lstStyle/>
-                    <a:p>
-                      <a:pPr algn="l">
-                        <a:defRPr sz="1050"/>
-                      </a:pPr>
-                      <a:r>
-                        <a:rPr sz="1050" b="1">
-                          <a:solidFill>
-                            <a:srgbClr val="11181C"/>
-                          </a:solidFill>
-                          <a:latin typeface="Arial"/>
-                        </a:rPr>
-                        <a:t>Offer Ferrari models that beat the Top 1 on features</a:t>
-                      </a:r>
-                      <a:endParaRPr sz="1050"/>
-                    </a:p>
-                  </a:txBody>
-                  <a:tcPr marL="50800" marR="50800" marT="25400" marB="25400" anchor="ctr">
-                    <a:lnL w="9525">
-                      <a:solidFill>
-                        <a:srgbClr val="E6E8EB"/>
-                      </a:solidFill>
-                    </a:lnL>
-                    <a:lnR w="9525">
-                      <a:solidFill>
-                        <a:srgbClr val="E6E8EB"/>
-                      </a:solidFill>
-                    </a:lnR>
-                    <a:lnT w="9525">
-                      <a:solidFill>
-                        <a:srgbClr val="E6E8EB"/>
-                      </a:solidFill>
-                    </a:lnT>
-                    <a:lnB w="9525">
-                      <a:solidFill>
-                        <a:srgbClr val="E6E8EB"/>
-                      </a:solidFill>
-                    </a:lnB>
-                    <a:noFill/>
-                  </a:tcPr>
-                </a:tc>
-                <a:tc>
-                  <a:txBody>
-                    <a:bodyPr wrap="square"/>
-                    <a:lstStyle/>
-                    <a:p>
-                      <a:pPr algn="l">
-                        <a:defRPr sz="950"/>
-                      </a:pPr>
-                      <a:r>
-                        <a:rPr sz="950" b="1">
-                          <a:solidFill>
-                            <a:srgbClr val="11181C"/>
-                          </a:solidFill>
-                          <a:latin typeface="Arial"/>
-                        </a:rPr>
-                        <a:t>Red Power</a:t>
-                      </a:r>
-                      <a:endParaRPr sz="950"/>
                     </a:p>
                   </a:txBody>
                   <a:tcPr marL="50800" marR="50800" marT="25400" marB="25400" anchor="ctr">
@@ -5408,7 +4404,7 @@
                           </a:solidFill>
                           <a:latin typeface="Arial"/>
                         </a:rPr>
-                        <a:t>Articulated linkage that adds working range and versatility. Amco Veba and Palfinger have their own version; Sany Palfinger has none.</a:t>
+                        <a:t>Medium 25 – 45 tm: 196 units, Rp 156 M. Heavy &gt; 45 tm: 65 units, Rp 115 M.</a:t>
                       </a:r>
                       <a:endParaRPr sz="950"/>
                     </a:p>
@@ -5438,36 +4434,7 @@
                   </a:tcPr>
                 </a:tc>
               </a:tr>
-              <a:tr h="323850">
-                <a:tc vMerge="1">
-                  <a:txBody>
-                    <a:bodyPr/>
-                    <a:lstStyle/>
-                    <a:p/>
-                  </a:txBody>
-                  <a:tcPr>
-                    <a:lnL w="9525">
-                      <a:solidFill>
-                        <a:srgbClr val="E6E8EB"/>
-                      </a:solidFill>
-                    </a:lnL>
-                    <a:lnR w="9525">
-                      <a:solidFill>
-                        <a:srgbClr val="E6E8EB"/>
-                      </a:solidFill>
-                    </a:lnR>
-                    <a:lnT w="9525">
-                      <a:solidFill>
-                        <a:srgbClr val="E6E8EB"/>
-                      </a:solidFill>
-                    </a:lnT>
-                    <a:lnB w="9525">
-                      <a:solidFill>
-                        <a:srgbClr val="E6E8EB"/>
-                      </a:solidFill>
-                    </a:lnB>
-                  </a:tcPr>
-                </a:tc>
+              <a:tr h="423862">
                 <a:tc vMerge="1">
                   <a:txBody>
                     <a:bodyPr/>
@@ -5503,18 +4470,62 @@
                     <a:lstStyle/>
                     <a:p>
                       <a:pPr algn="l">
-                        <a:defRPr sz="950"/>
+                        <a:defRPr sz="1000"/>
                       </a:pPr>
                       <a:r>
-                        <a:rPr sz="950" b="1">
+                        <a:rPr sz="1000" b="1">
                           <a:solidFill>
                             <a:srgbClr val="11181C"/>
                           </a:solidFill>
                           <a:latin typeface="Arial"/>
                         </a:rPr>
-                        <a:t>SDV (Smooth Descent Valve)</a:t>
+                        <a:t>Targeting</a:t>
                       </a:r>
-                      <a:endParaRPr sz="950"/>
+                      <a:endParaRPr sz="1000"/>
+                    </a:p>
+                  </a:txBody>
+                  <a:tcPr marL="50800" marR="50800" marT="25400" marB="25400" anchor="ctr">
+                    <a:lnL w="9525">
+                      <a:solidFill>
+                        <a:srgbClr val="E6E8EB"/>
+                      </a:solidFill>
+                    </a:lnL>
+                    <a:lnR w="9525">
+                      <a:solidFill>
+                        <a:srgbClr val="E6E8EB"/>
+                      </a:solidFill>
+                    </a:lnR>
+                    <a:lnT w="9525">
+                      <a:solidFill>
+                        <a:srgbClr val="E6E8EB"/>
+                      </a:solidFill>
+                    </a:lnT>
+                    <a:lnB w="9525">
+                      <a:solidFill>
+                        <a:srgbClr val="E6E8EB"/>
+                      </a:solidFill>
+                    </a:lnB>
+                    <a:noFill/>
+                  </a:tcPr>
+                </a:tc>
+                <a:tc>
+                  <a:txBody>
+                    <a:bodyPr wrap="square"/>
+                    <a:lstStyle/>
+                    <a:p>
+                      <a:pPr algn="l">
+                        <a:defRPr sz="1000"/>
+                      </a:pPr>
+                      <a:r>
+                        <a:rPr sz="1000" b="1">
+                          <a:solidFill>
+                            <a:srgbClr val="11181C"/>
+                          </a:solidFill>
+                          <a:latin typeface="Arial"/>
+                        </a:rPr>
+                        <a:t>Take share from the Top 1 model in each tier</a:t>
+                      </a:r>
+                      <a:endParaRPr sz="1000"/>
                     </a:p>
                   </a:txBody>
                   <a:tcPr marL="50800" marR="50800" marT="25400" marB="25400" anchor="ctr">
@@ -5556,7 +4567,7 @@
                           </a:solidFill>
                           <a:latin typeface="Arial"/>
                         </a:rPr>
-                        <a:t>Cuts boom flex and dynamic load when lowering. Amco Veba and Sany Palfinger have no equal.</a:t>
+                        <a:t>Medium: Sany Palfinger SPK32080, SPK36080, SPK42502. Heavy: Palfinger PK 53002, PK 76002, PK 88002.</a:t>
                       </a:r>
                       <a:endParaRPr sz="950"/>
                     </a:p>
@@ -5586,36 +4597,7 @@
                   </a:tcPr>
                 </a:tc>
               </a:tr>
-              <a:tr h="323850">
-                <a:tc vMerge="1">
-                  <a:txBody>
-                    <a:bodyPr/>
-                    <a:lstStyle/>
-                    <a:p/>
-                  </a:txBody>
-                  <a:tcPr>
-                    <a:lnL w="9525">
-                      <a:solidFill>
-                        <a:srgbClr val="E6E8EB"/>
-                      </a:solidFill>
-                    </a:lnL>
-                    <a:lnR w="9525">
-                      <a:solidFill>
-                        <a:srgbClr val="E6E8EB"/>
-                      </a:solidFill>
-                    </a:lnR>
-                    <a:lnT w="9525">
-                      <a:solidFill>
-                        <a:srgbClr val="E6E8EB"/>
-                      </a:solidFill>
-                    </a:lnT>
-                    <a:lnB w="9525">
-                      <a:solidFill>
-                        <a:srgbClr val="E6E8EB"/>
-                      </a:solidFill>
-                    </a:lnB>
-                  </a:tcPr>
-                </a:tc>
+              <a:tr h="423862">
                 <a:tc vMerge="1">
                   <a:txBody>
                     <a:bodyPr/>
@@ -5651,18 +4633,62 @@
                     <a:lstStyle/>
                     <a:p>
                       <a:pPr algn="l">
-                        <a:defRPr sz="950"/>
+                        <a:defRPr sz="1000"/>
                       </a:pPr>
                       <a:r>
-                        <a:rPr sz="950" b="1">
+                        <a:rPr sz="1000" b="1">
                           <a:solidFill>
                             <a:srgbClr val="11181C"/>
                           </a:solidFill>
                           <a:latin typeface="Arial"/>
                         </a:rPr>
-                        <a:t>Magic Touch</a:t>
+                        <a:t>Positioning</a:t>
                       </a:r>
-                      <a:endParaRPr sz="950"/>
+                      <a:endParaRPr sz="1000"/>
+                    </a:p>
+                  </a:txBody>
+                  <a:tcPr marL="50800" marR="50800" marT="25400" marB="25400" anchor="ctr">
+                    <a:lnL w="9525">
+                      <a:solidFill>
+                        <a:srgbClr val="E6E8EB"/>
+                      </a:solidFill>
+                    </a:lnL>
+                    <a:lnR w="9525">
+                      <a:solidFill>
+                        <a:srgbClr val="E6E8EB"/>
+                      </a:solidFill>
+                    </a:lnR>
+                    <a:lnT w="9525">
+                      <a:solidFill>
+                        <a:srgbClr val="E6E8EB"/>
+                      </a:solidFill>
+                    </a:lnT>
+                    <a:lnB w="9525">
+                      <a:solidFill>
+                        <a:srgbClr val="E6E8EB"/>
+                      </a:solidFill>
+                    </a:lnB>
+                    <a:noFill/>
+                  </a:tcPr>
+                </a:tc>
+                <a:tc>
+                  <a:txBody>
+                    <a:bodyPr wrap="square"/>
+                    <a:lstStyle/>
+                    <a:p>
+                      <a:pPr algn="l">
+                        <a:defRPr sz="1000"/>
+                      </a:pPr>
+                      <a:r>
+                        <a:rPr sz="1000" b="1">
+                          <a:solidFill>
+                            <a:srgbClr val="11181C"/>
+                          </a:solidFill>
+                          <a:latin typeface="Arial"/>
+                        </a:rPr>
+                        <a:t>Two clear promises</a:t>
+                      </a:r>
+                      <a:endParaRPr sz="1000"/>
                     </a:p>
                   </a:txBody>
                   <a:tcPr marL="50800" marR="50800" marT="25400" marB="25400" anchor="ctr">
@@ -5704,7 +4730,7 @@
                           </a:solidFill>
                           <a:latin typeface="Arial"/>
                         </a:rPr>
-                        <a:t>Opens and stows the crane automatically from the cab. Sany Palfinger has no equal.</a:t>
+                        <a:t>XCMG: same capacity, lower price (SQZ365.4 −9% vs SPK36080). Ferrari: European features, cheaper where it wins (−23% at 25 – 30 tm, −32% at 45 – 50 tm) and faster delivery from China stock (~14 weeks).</a:t>
                       </a:r>
                       <a:endParaRPr sz="950"/>
                     </a:p>
@@ -5734,14 +4760,28 @@
                   </a:tcPr>
                 </a:tc>
               </a:tr>
-              <a:tr h="323850">
-                <a:tc vMerge="1">
+              <a:tr h="423862">
+                <a:tc rowSpan="4">
                   <a:txBody>
-                    <a:bodyPr/>
+                    <a:bodyPr wrap="square"/>
                     <a:lstStyle/>
-                    <a:p/>
+                    <a:p>
+                      <a:pPr algn="ctr">
+                        <a:defRPr sz="1200"/>
+                      </a:pPr>
+                      <a:r>
+                        <a:rPr sz="1200" b="1">
+                          <a:solidFill>
+                            <a:srgbClr val="076932"/>
+                          </a:solidFill>
+                          <a:latin typeface="Arial"/>
+                        </a:rPr>
+                        <a:t>4P</a:t>
+                      </a:r>
+                      <a:endParaRPr sz="1200"/>
+                    </a:p>
                   </a:txBody>
-                  <a:tcPr>
+                  <a:tcPr marL="50800" marR="50800" marT="25400" marB="25400" anchor="ctr">
                     <a:lnL w="9525">
                       <a:solidFill>
                         <a:srgbClr val="E6E8EB"/>
@@ -5762,35 +4802,7 @@
                         <a:srgbClr val="E6E8EB"/>
                       </a:solidFill>
                     </a:lnB>
-                  </a:tcPr>
-                </a:tc>
-                <a:tc vMerge="1">
-                  <a:txBody>
-                    <a:bodyPr/>
-                    <a:lstStyle/>
-                    <a:p/>
-                  </a:txBody>
-                  <a:tcPr>
-                    <a:lnL w="9525">
-                      <a:solidFill>
-                        <a:srgbClr val="E6E8EB"/>
-                      </a:solidFill>
-                    </a:lnL>
-                    <a:lnR w="9525">
-                      <a:solidFill>
-                        <a:srgbClr val="E6E8EB"/>
-                      </a:solidFill>
-                    </a:lnR>
-                    <a:lnT w="9525">
-                      <a:solidFill>
-                        <a:srgbClr val="E6E8EB"/>
-                      </a:solidFill>
-                    </a:lnT>
-                    <a:lnB w="9525">
-                      <a:solidFill>
-                        <a:srgbClr val="E6E8EB"/>
-                      </a:solidFill>
-                    </a:lnB>
+                    <a:noFill/>
                   </a:tcPr>
                 </a:tc>
                 <a:tc>
@@ -5799,18 +4811,62 @@
                     <a:lstStyle/>
                     <a:p>
                       <a:pPr algn="l">
-                        <a:defRPr sz="950"/>
+                        <a:defRPr sz="1000"/>
                       </a:pPr>
                       <a:r>
-                        <a:rPr sz="950" b="1">
+                        <a:rPr sz="1000" b="1">
                           <a:solidFill>
                             <a:srgbClr val="11181C"/>
                           </a:solidFill>
                           <a:latin typeface="Arial"/>
                         </a:rPr>
-                        <a:t>PB (Power Boost)*</a:t>
+                        <a:t>Product</a:t>
                       </a:r>
-                      <a:endParaRPr sz="950"/>
+                      <a:endParaRPr sz="1000"/>
+                    </a:p>
+                  </a:txBody>
+                  <a:tcPr marL="50800" marR="50800" marT="25400" marB="25400" anchor="ctr">
+                    <a:lnL w="9525">
+                      <a:solidFill>
+                        <a:srgbClr val="E6E8EB"/>
+                      </a:solidFill>
+                    </a:lnL>
+                    <a:lnR w="9525">
+                      <a:solidFill>
+                        <a:srgbClr val="E6E8EB"/>
+                      </a:solidFill>
+                    </a:lnR>
+                    <a:lnT w="9525">
+                      <a:solidFill>
+                        <a:srgbClr val="E6E8EB"/>
+                      </a:solidFill>
+                    </a:lnT>
+                    <a:lnB w="9525">
+                      <a:solidFill>
+                        <a:srgbClr val="E6E8EB"/>
+                      </a:solidFill>
+                    </a:lnB>
+                    <a:noFill/>
+                  </a:tcPr>
+                </a:tc>
+                <a:tc>
+                  <a:txBody>
+                    <a:bodyPr wrap="square"/>
+                    <a:lstStyle/>
+                    <a:p>
+                      <a:pPr algn="l">
+                        <a:defRPr sz="1000"/>
+                      </a:pPr>
+                      <a:r>
+                        <a:rPr sz="1000" b="1">
+                          <a:solidFill>
+                            <a:srgbClr val="11181C"/>
+                          </a:solidFill>
+                          <a:latin typeface="Arial"/>
+                        </a:rPr>
+                        <a:t>Offer Ferrari models that beat the Top 1 on features</a:t>
+                      </a:r>
+                      <a:endParaRPr sz="1000"/>
                     </a:p>
                   </a:txBody>
                   <a:tcPr marL="50800" marR="50800" marT="25400" marB="25400" anchor="ctr">
@@ -5852,7 +4908,7 @@
                           </a:solidFill>
                           <a:latin typeface="Arial"/>
                         </a:rPr>
-                        <a:t>Extra lifting capacity on demand. Equal to Palfinger HPLS and Amco Veba AVPS.</a:t>
+                        <a:t>Red Power (more working range), SDV (less boom flex), Magic Touch (auto open/stow): Sany Palfinger has none. PB, RS, ECM: equal to Palfinger.</a:t>
                       </a:r>
                       <a:endParaRPr sz="950"/>
                     </a:p>
@@ -5882,36 +4938,7 @@
                   </a:tcPr>
                 </a:tc>
               </a:tr>
-              <a:tr h="323850">
-                <a:tc vMerge="1">
-                  <a:txBody>
-                    <a:bodyPr/>
-                    <a:lstStyle/>
-                    <a:p/>
-                  </a:txBody>
-                  <a:tcPr>
-                    <a:lnL w="9525">
-                      <a:solidFill>
-                        <a:srgbClr val="E6E8EB"/>
-                      </a:solidFill>
-                    </a:lnL>
-                    <a:lnR w="9525">
-                      <a:solidFill>
-                        <a:srgbClr val="E6E8EB"/>
-                      </a:solidFill>
-                    </a:lnR>
-                    <a:lnT w="9525">
-                      <a:solidFill>
-                        <a:srgbClr val="E6E8EB"/>
-                      </a:solidFill>
-                    </a:lnT>
-                    <a:lnB w="9525">
-                      <a:solidFill>
-                        <a:srgbClr val="E6E8EB"/>
-                      </a:solidFill>
-                    </a:lnB>
-                  </a:tcPr>
-                </a:tc>
+              <a:tr h="423862">
                 <a:tc vMerge="1">
                   <a:txBody>
                     <a:bodyPr/>
@@ -5947,18 +4974,62 @@
                     <a:lstStyle/>
                     <a:p>
                       <a:pPr algn="l">
-                        <a:defRPr sz="950"/>
+                        <a:defRPr sz="1000"/>
                       </a:pPr>
                       <a:r>
-                        <a:rPr sz="950" b="1">
+                        <a:rPr sz="1000" b="1">
                           <a:solidFill>
                             <a:srgbClr val="11181C"/>
                           </a:solidFill>
                           <a:latin typeface="Arial"/>
                         </a:rPr>
-                        <a:t>RS*</a:t>
+                        <a:t>Price</a:t>
                       </a:r>
-                      <a:endParaRPr sz="950"/>
+                      <a:endParaRPr sz="1000"/>
+                    </a:p>
+                  </a:txBody>
+                  <a:tcPr marL="50800" marR="50800" marT="25400" marB="25400" anchor="ctr">
+                    <a:lnL w="9525">
+                      <a:solidFill>
+                        <a:srgbClr val="E6E8EB"/>
+                      </a:solidFill>
+                    </a:lnL>
+                    <a:lnR w="9525">
+                      <a:solidFill>
+                        <a:srgbClr val="E6E8EB"/>
+                      </a:solidFill>
+                    </a:lnR>
+                    <a:lnT w="9525">
+                      <a:solidFill>
+                        <a:srgbClr val="E6E8EB"/>
+                      </a:solidFill>
+                    </a:lnT>
+                    <a:lnB w="9525">
+                      <a:solidFill>
+                        <a:srgbClr val="E6E8EB"/>
+                      </a:solidFill>
+                    </a:lnB>
+                    <a:noFill/>
+                  </a:tcPr>
+                </a:tc>
+                <a:tc>
+                  <a:txBody>
+                    <a:bodyPr wrap="square"/>
+                    <a:lstStyle/>
+                    <a:p>
+                      <a:pPr algn="l">
+                        <a:defRPr sz="1000"/>
+                      </a:pPr>
+                      <a:r>
+                        <a:rPr sz="1000" b="1">
+                          <a:solidFill>
+                            <a:srgbClr val="11181C"/>
+                          </a:solidFill>
+                          <a:latin typeface="Arial"/>
+                        </a:rPr>
+                        <a:t>Negotiate a better price with Ferrari and XCMG</a:t>
+                      </a:r>
+                      <a:endParaRPr sz="1000"/>
                     </a:p>
                   </a:txBody>
                   <a:tcPr marL="50800" marR="50800" marT="25400" marB="25400" anchor="ctr">
@@ -6000,7 +5071,7 @@
                           </a:solidFill>
                           <a:latin typeface="Arial"/>
                         </a:rPr>
-                        <a:t>Faster boom extension. Equal to Palfinger High Speed Extension; Amco Veba has none.</a:t>
+                        <a:t>Ferrari: lower price on 746 A4 (+48%), 9601CR A8 (+85%), 990R (+79%). XCMG: Triatra special price on SQZ325.4 and SQZ365.4.</a:t>
                       </a:r>
                       <a:endParaRPr sz="950"/>
                     </a:p>
@@ -6030,36 +5101,7 @@
                   </a:tcPr>
                 </a:tc>
               </a:tr>
-              <a:tr h="323850">
-                <a:tc vMerge="1">
-                  <a:txBody>
-                    <a:bodyPr/>
-                    <a:lstStyle/>
-                    <a:p/>
-                  </a:txBody>
-                  <a:tcPr>
-                    <a:lnL w="9525">
-                      <a:solidFill>
-                        <a:srgbClr val="E6E8EB"/>
-                      </a:solidFill>
-                    </a:lnL>
-                    <a:lnR w="9525">
-                      <a:solidFill>
-                        <a:srgbClr val="E6E8EB"/>
-                      </a:solidFill>
-                    </a:lnR>
-                    <a:lnT w="9525">
-                      <a:solidFill>
-                        <a:srgbClr val="E6E8EB"/>
-                      </a:solidFill>
-                    </a:lnT>
-                    <a:lnB w="9525">
-                      <a:solidFill>
-                        <a:srgbClr val="E6E8EB"/>
-                      </a:solidFill>
-                    </a:lnB>
-                  </a:tcPr>
-                </a:tc>
+              <a:tr h="423862">
                 <a:tc vMerge="1">
                   <a:txBody>
                     <a:bodyPr/>
@@ -6095,18 +5137,62 @@
                     <a:lstStyle/>
                     <a:p>
                       <a:pPr algn="l">
-                        <a:defRPr sz="950"/>
+                        <a:defRPr sz="1000"/>
                       </a:pPr>
                       <a:r>
-                        <a:rPr sz="950" b="1">
+                        <a:rPr sz="1000" b="1">
                           <a:solidFill>
                             <a:srgbClr val="11181C"/>
                           </a:solidFill>
                           <a:latin typeface="Arial"/>
                         </a:rPr>
-                        <a:t>ECM*</a:t>
+                        <a:t>Place</a:t>
                       </a:r>
-                      <a:endParaRPr sz="950"/>
+                      <a:endParaRPr sz="1000"/>
+                    </a:p>
+                  </a:txBody>
+                  <a:tcPr marL="50800" marR="50800" marT="25400" marB="25400" anchor="ctr">
+                    <a:lnL w="9525">
+                      <a:solidFill>
+                        <a:srgbClr val="E6E8EB"/>
+                      </a:solidFill>
+                    </a:lnL>
+                    <a:lnR w="9525">
+                      <a:solidFill>
+                        <a:srgbClr val="E6E8EB"/>
+                      </a:solidFill>
+                    </a:lnR>
+                    <a:lnT w="9525">
+                      <a:solidFill>
+                        <a:srgbClr val="E6E8EB"/>
+                      </a:solidFill>
+                    </a:lnT>
+                    <a:lnB w="9525">
+                      <a:solidFill>
+                        <a:srgbClr val="E6E8EB"/>
+                      </a:solidFill>
+                    </a:lnB>
+                    <a:noFill/>
+                  </a:tcPr>
+                </a:tc>
+                <a:tc>
+                  <a:txBody>
+                    <a:bodyPr wrap="square"/>
+                    <a:lstStyle/>
+                    <a:p>
+                      <a:pPr algn="l">
+                        <a:defRPr sz="1000"/>
+                      </a:pPr>
+                      <a:r>
+                        <a:rPr sz="1000" b="1">
+                          <a:solidFill>
+                            <a:srgbClr val="11181C"/>
+                          </a:solidFill>
+                          <a:latin typeface="Arial"/>
+                        </a:rPr>
+                        <a:t>Negotiate stock to cut lead time</a:t>
+                      </a:r>
+                      <a:endParaRPr sz="1000"/>
                     </a:p>
                   </a:txBody>
                   <a:tcPr marL="50800" marR="50800" marT="25400" marB="25400" anchor="ctr">
@@ -6148,7 +5234,7 @@
                           </a:solidFill>
                           <a:latin typeface="Arial"/>
                         </a:rPr>
-                        <a:t>Electronic control and overload protection. Equal to Palfinger PALTRONIC and Amco Veba EBB.</a:t>
+                        <a:t>Ferrari stocks 268 A4 and FBR450R A4 in China (14-week lead time) and main components in Malaysia. XCMG via GM Tractors.</a:t>
                       </a:r>
                       <a:endParaRPr sz="950"/>
                     </a:p>
@@ -6178,69 +5264,54 @@
                   </a:tcPr>
                 </a:tc>
               </a:tr>
-              <a:tr h="323850">
-                <a:tc rowSpan="2">
+              <a:tr h="423862">
+                <a:tc vMerge="1">
+                  <a:txBody>
+                    <a:bodyPr/>
+                    <a:lstStyle/>
+                    <a:p/>
+                  </a:txBody>
+                  <a:tcPr>
+                    <a:lnL w="9525">
+                      <a:solidFill>
+                        <a:srgbClr val="E6E8EB"/>
+                      </a:solidFill>
+                    </a:lnL>
+                    <a:lnR w="9525">
+                      <a:solidFill>
+                        <a:srgbClr val="E6E8EB"/>
+                      </a:solidFill>
+                    </a:lnR>
+                    <a:lnT w="9525">
+                      <a:solidFill>
+                        <a:srgbClr val="E6E8EB"/>
+                      </a:solidFill>
+                    </a:lnT>
+                    <a:lnB w="9525">
+                      <a:solidFill>
+                        <a:srgbClr val="E6E8EB"/>
+                      </a:solidFill>
+                    </a:lnB>
+                  </a:tcPr>
+                </a:tc>
+                <a:tc>
                   <a:txBody>
                     <a:bodyPr wrap="square"/>
                     <a:lstStyle/>
                     <a:p>
                       <a:pPr algn="l">
-                        <a:defRPr sz="1100"/>
+                        <a:defRPr sz="1000"/>
                       </a:pPr>
                       <a:r>
-                        <a:rPr sz="1100" b="1">
-                          <a:solidFill>
-                            <a:srgbClr val="076932"/>
-                          </a:solidFill>
-                          <a:latin typeface="Arial"/>
-                        </a:rPr>
-                        <a:t>Price</a:t>
-                      </a:r>
-                      <a:endParaRPr sz="1100"/>
-                    </a:p>
-                  </a:txBody>
-                  <a:tcPr marL="50800" marR="50800" marT="25400" marB="25400" anchor="ctr">
-                    <a:lnL w="9525">
-                      <a:solidFill>
-                        <a:srgbClr val="E6E8EB"/>
-                      </a:solidFill>
-                    </a:lnL>
-                    <a:lnR w="9525">
-                      <a:solidFill>
-                        <a:srgbClr val="E6E8EB"/>
-                      </a:solidFill>
-                    </a:lnR>
-                    <a:lnT w="9525">
-                      <a:solidFill>
-                        <a:srgbClr val="E6E8EB"/>
-                      </a:solidFill>
-                    </a:lnT>
-                    <a:lnB w="9525">
-                      <a:solidFill>
-                        <a:srgbClr val="E6E8EB"/>
-                      </a:solidFill>
-                    </a:lnB>
-                    <a:noFill/>
-                  </a:tcPr>
-                </a:tc>
-                <a:tc rowSpan="2">
-                  <a:txBody>
-                    <a:bodyPr wrap="square"/>
-                    <a:lstStyle/>
-                    <a:p>
-                      <a:pPr algn="l">
-                        <a:defRPr sz="1050"/>
-                      </a:pPr>
-                      <a:r>
-                        <a:rPr sz="1050" b="1">
+                        <a:rPr sz="1000" b="1">
                           <a:solidFill>
                             <a:srgbClr val="11181C"/>
                           </a:solidFill>
                           <a:latin typeface="Arial"/>
                         </a:rPr>
-                        <a:t>Negotiate a better price with F.lli Ferrari and XCMG</a:t>
+                        <a:t>Promotion</a:t>
                       </a:r>
-                      <a:endParaRPr sz="1050"/>
+                      <a:endParaRPr sz="1000"/>
                     </a:p>
                   </a:txBody>
                   <a:tcPr marL="50800" marR="50800" marT="25400" marB="25400" anchor="ctr">
@@ -6273,18 +5344,18 @@
                     <a:lstStyle/>
                     <a:p>
                       <a:pPr algn="l">
-                        <a:defRPr sz="950"/>
+                        <a:defRPr sz="1000"/>
                       </a:pPr>
                       <a:r>
-                        <a:rPr sz="950" b="1">
+                        <a:rPr sz="1000" b="1">
                           <a:solidFill>
                             <a:srgbClr val="11181C"/>
                           </a:solidFill>
                           <a:latin typeface="Arial"/>
                         </a:rPr>
-                        <a:t>Ferrari 746 A4 · 9601CR A8 · 990R</a:t>
+                        <a:t>Sell a ready-to-work package</a:t>
                       </a:r>
-                      <a:endParaRPr sz="950"/>
+                      <a:endParaRPr sz="1000"/>
                     </a:p>
                   </a:txBody>
                   <a:tcPr marL="50800" marR="50800" marT="25400" marB="25400" anchor="ctr">
@@ -6326,955 +5397,7 @@
                           </a:solidFill>
                           <a:latin typeface="Arial"/>
                         </a:rPr>
-                        <a:t>Ask for a lower price: 40–45 tm (+48%), 50–55 tm (+85%), 70–75 tm (+79%) vs the Top 1.</a:t>
-                      </a:r>
-                      <a:endParaRPr sz="950"/>
-                    </a:p>
-                  </a:txBody>
-                  <a:tcPr marL="50800" marR="50800" marT="25400" marB="25400" anchor="ctr">
-                    <a:lnL w="9525">
-                      <a:solidFill>
-                        <a:srgbClr val="E6E8EB"/>
-                      </a:solidFill>
-                    </a:lnL>
-                    <a:lnR w="9525">
-                      <a:solidFill>
-                        <a:srgbClr val="E6E8EB"/>
-                      </a:solidFill>
-                    </a:lnR>
-                    <a:lnT w="9525">
-                      <a:solidFill>
-                        <a:srgbClr val="E6E8EB"/>
-                      </a:solidFill>
-                    </a:lnT>
-                    <a:lnB w="9525">
-                      <a:solidFill>
-                        <a:srgbClr val="E6E8EB"/>
-                      </a:solidFill>
-                    </a:lnB>
-                    <a:noFill/>
-                  </a:tcPr>
-                </a:tc>
-              </a:tr>
-              <a:tr h="323850">
-                <a:tc vMerge="1">
-                  <a:txBody>
-                    <a:bodyPr/>
-                    <a:lstStyle/>
-                    <a:p/>
-                  </a:txBody>
-                  <a:tcPr>
-                    <a:lnL w="9525">
-                      <a:solidFill>
-                        <a:srgbClr val="E6E8EB"/>
-                      </a:solidFill>
-                    </a:lnL>
-                    <a:lnR w="9525">
-                      <a:solidFill>
-                        <a:srgbClr val="E6E8EB"/>
-                      </a:solidFill>
-                    </a:lnR>
-                    <a:lnT w="9525">
-                      <a:solidFill>
-                        <a:srgbClr val="E6E8EB"/>
-                      </a:solidFill>
-                    </a:lnT>
-                    <a:lnB w="9525">
-                      <a:solidFill>
-                        <a:srgbClr val="E6E8EB"/>
-                      </a:solidFill>
-                    </a:lnB>
-                  </a:tcPr>
-                </a:tc>
-                <a:tc vMerge="1">
-                  <a:txBody>
-                    <a:bodyPr/>
-                    <a:lstStyle/>
-                    <a:p/>
-                  </a:txBody>
-                  <a:tcPr>
-                    <a:lnL w="9525">
-                      <a:solidFill>
-                        <a:srgbClr val="E6E8EB"/>
-                      </a:solidFill>
-                    </a:lnL>
-                    <a:lnR w="9525">
-                      <a:solidFill>
-                        <a:srgbClr val="E6E8EB"/>
-                      </a:solidFill>
-                    </a:lnR>
-                    <a:lnT w="9525">
-                      <a:solidFill>
-                        <a:srgbClr val="E6E8EB"/>
-                      </a:solidFill>
-                    </a:lnT>
-                    <a:lnB w="9525">
-                      <a:solidFill>
-                        <a:srgbClr val="E6E8EB"/>
-                      </a:solidFill>
-                    </a:lnB>
-                  </a:tcPr>
-                </a:tc>
-                <a:tc>
-                  <a:txBody>
-                    <a:bodyPr wrap="square"/>
-                    <a:lstStyle/>
-                    <a:p>
-                      <a:pPr algn="l">
-                        <a:defRPr sz="950"/>
-                      </a:pPr>
-                      <a:r>
-                        <a:rPr sz="950" b="1">
-                          <a:solidFill>
-                            <a:srgbClr val="11181C"/>
-                          </a:solidFill>
-                          <a:latin typeface="Arial"/>
-                        </a:rPr>
-                        <a:t>XCMG SQZ325.4 · SQZ365.4</a:t>
-                      </a:r>
-                      <a:endParaRPr sz="950"/>
-                    </a:p>
-                  </a:txBody>
-                  <a:tcPr marL="50800" marR="50800" marT="25400" marB="25400" anchor="ctr">
-                    <a:lnL w="9525">
-                      <a:solidFill>
-                        <a:srgbClr val="E6E8EB"/>
-                      </a:solidFill>
-                    </a:lnL>
-                    <a:lnR w="9525">
-                      <a:solidFill>
-                        <a:srgbClr val="E6E8EB"/>
-                      </a:solidFill>
-                    </a:lnR>
-                    <a:lnT w="9525">
-                      <a:solidFill>
-                        <a:srgbClr val="E6E8EB"/>
-                      </a:solidFill>
-                    </a:lnT>
-                    <a:lnB w="9525">
-                      <a:solidFill>
-                        <a:srgbClr val="E6E8EB"/>
-                      </a:solidFill>
-                    </a:lnB>
-                    <a:noFill/>
-                  </a:tcPr>
-                </a:tc>
-                <a:tc>
-                  <a:txBody>
-                    <a:bodyPr wrap="square"/>
-                    <a:lstStyle/>
-                    <a:p>
-                      <a:pPr algn="l">
-                        <a:defRPr sz="950"/>
-                      </a:pPr>
-                      <a:r>
-                        <a:rPr sz="950" b="0">
-                          <a:solidFill>
-                            <a:srgbClr val="11181C"/>
-                          </a:solidFill>
-                          <a:latin typeface="Arial"/>
-                        </a:rPr>
-                        <a:t>Ask for a Triatra special price: 30–35 tm (+4%), 35–40 tm (−9%).</a:t>
-                      </a:r>
-                      <a:endParaRPr sz="950"/>
-                    </a:p>
-                  </a:txBody>
-                  <a:tcPr marL="50800" marR="50800" marT="25400" marB="25400" anchor="ctr">
-                    <a:lnL w="9525">
-                      <a:solidFill>
-                        <a:srgbClr val="E6E8EB"/>
-                      </a:solidFill>
-                    </a:lnL>
-                    <a:lnR w="9525">
-                      <a:solidFill>
-                        <a:srgbClr val="E6E8EB"/>
-                      </a:solidFill>
-                    </a:lnR>
-                    <a:lnT w="9525">
-                      <a:solidFill>
-                        <a:srgbClr val="E6E8EB"/>
-                      </a:solidFill>
-                    </a:lnT>
-                    <a:lnB w="9525">
-                      <a:solidFill>
-                        <a:srgbClr val="E6E8EB"/>
-                      </a:solidFill>
-                    </a:lnB>
-                    <a:noFill/>
-                  </a:tcPr>
-                </a:tc>
-              </a:tr>
-              <a:tr h="323850">
-                <a:tc rowSpan="3">
-                  <a:txBody>
-                    <a:bodyPr wrap="square"/>
-                    <a:lstStyle/>
-                    <a:p>
-                      <a:pPr algn="l">
-                        <a:defRPr sz="1100"/>
-                      </a:pPr>
-                      <a:r>
-                        <a:rPr sz="1100" b="1">
-                          <a:solidFill>
-                            <a:srgbClr val="076932"/>
-                          </a:solidFill>
-                          <a:latin typeface="Arial"/>
-                        </a:rPr>
-                        <a:t>Place</a:t>
-                      </a:r>
-                      <a:endParaRPr sz="1100"/>
-                    </a:p>
-                  </a:txBody>
-                  <a:tcPr marL="50800" marR="50800" marT="25400" marB="25400" anchor="ctr">
-                    <a:lnL w="9525">
-                      <a:solidFill>
-                        <a:srgbClr val="E6E8EB"/>
-                      </a:solidFill>
-                    </a:lnL>
-                    <a:lnR w="9525">
-                      <a:solidFill>
-                        <a:srgbClr val="E6E8EB"/>
-                      </a:solidFill>
-                    </a:lnR>
-                    <a:lnT w="9525">
-                      <a:solidFill>
-                        <a:srgbClr val="E6E8EB"/>
-                      </a:solidFill>
-                    </a:lnT>
-                    <a:lnB w="9525">
-                      <a:solidFill>
-                        <a:srgbClr val="E6E8EB"/>
-                      </a:solidFill>
-                    </a:lnB>
-                    <a:noFill/>
-                  </a:tcPr>
-                </a:tc>
-                <a:tc rowSpan="3">
-                  <a:txBody>
-                    <a:bodyPr wrap="square"/>
-                    <a:lstStyle/>
-                    <a:p>
-                      <a:pPr algn="l">
-                        <a:defRPr sz="1050"/>
-                      </a:pPr>
-                      <a:r>
-                        <a:rPr sz="1050" b="1">
-                          <a:solidFill>
-                            <a:srgbClr val="11181C"/>
-                          </a:solidFill>
-                          <a:latin typeface="Arial"/>
-                        </a:rPr>
-                        <a:t>Negotiate stock to cut lead time</a:t>
-                      </a:r>
-                      <a:endParaRPr sz="1050"/>
-                    </a:p>
-                  </a:txBody>
-                  <a:tcPr marL="50800" marR="50800" marT="25400" marB="25400" anchor="ctr">
-                    <a:lnL w="9525">
-                      <a:solidFill>
-                        <a:srgbClr val="E6E8EB"/>
-                      </a:solidFill>
-                    </a:lnL>
-                    <a:lnR w="9525">
-                      <a:solidFill>
-                        <a:srgbClr val="E6E8EB"/>
-                      </a:solidFill>
-                    </a:lnR>
-                    <a:lnT w="9525">
-                      <a:solidFill>
-                        <a:srgbClr val="E6E8EB"/>
-                      </a:solidFill>
-                    </a:lnT>
-                    <a:lnB w="9525">
-                      <a:solidFill>
-                        <a:srgbClr val="E6E8EB"/>
-                      </a:solidFill>
-                    </a:lnB>
-                    <a:noFill/>
-                  </a:tcPr>
-                </a:tc>
-                <a:tc>
-                  <a:txBody>
-                    <a:bodyPr wrap="square"/>
-                    <a:lstStyle/>
-                    <a:p>
-                      <a:pPr algn="l">
-                        <a:defRPr sz="950"/>
-                      </a:pPr>
-                      <a:r>
-                        <a:rPr sz="950" b="1">
-                          <a:solidFill>
-                            <a:srgbClr val="11181C"/>
-                          </a:solidFill>
-                          <a:latin typeface="Arial"/>
-                        </a:rPr>
-                        <a:t>Ferrari 268 A4 · FBR450R A4</a:t>
-                      </a:r>
-                      <a:endParaRPr sz="950"/>
-                    </a:p>
-                  </a:txBody>
-                  <a:tcPr marL="50800" marR="50800" marT="25400" marB="25400" anchor="ctr">
-                    <a:lnL w="9525">
-                      <a:solidFill>
-                        <a:srgbClr val="E6E8EB"/>
-                      </a:solidFill>
-                    </a:lnL>
-                    <a:lnR w="9525">
-                      <a:solidFill>
-                        <a:srgbClr val="E6E8EB"/>
-                      </a:solidFill>
-                    </a:lnR>
-                    <a:lnT w="9525">
-                      <a:solidFill>
-                        <a:srgbClr val="E6E8EB"/>
-                      </a:solidFill>
-                    </a:lnT>
-                    <a:lnB w="9525">
-                      <a:solidFill>
-                        <a:srgbClr val="E6E8EB"/>
-                      </a:solidFill>
-                    </a:lnB>
-                    <a:noFill/>
-                  </a:tcPr>
-                </a:tc>
-                <a:tc>
-                  <a:txBody>
-                    <a:bodyPr wrap="square"/>
-                    <a:lstStyle/>
-                    <a:p>
-                      <a:pPr algn="l">
-                        <a:defRPr sz="950"/>
-                      </a:pPr>
-                      <a:r>
-                        <a:rPr sz="950" b="0">
-                          <a:solidFill>
-                            <a:srgbClr val="11181C"/>
-                          </a:solidFill>
-                          <a:latin typeface="Arial"/>
-                        </a:rPr>
-                        <a:t>Stock at the Ferrari China factory for a 14-week lead time (25–30 tm −23%, 45–50 tm −32%).</a:t>
-                      </a:r>
-                      <a:endParaRPr sz="950"/>
-                    </a:p>
-                  </a:txBody>
-                  <a:tcPr marL="50800" marR="50800" marT="25400" marB="25400" anchor="ctr">
-                    <a:lnL w="9525">
-                      <a:solidFill>
-                        <a:srgbClr val="E6E8EB"/>
-                      </a:solidFill>
-                    </a:lnL>
-                    <a:lnR w="9525">
-                      <a:solidFill>
-                        <a:srgbClr val="E6E8EB"/>
-                      </a:solidFill>
-                    </a:lnR>
-                    <a:lnT w="9525">
-                      <a:solidFill>
-                        <a:srgbClr val="E6E8EB"/>
-                      </a:solidFill>
-                    </a:lnT>
-                    <a:lnB w="9525">
-                      <a:solidFill>
-                        <a:srgbClr val="E6E8EB"/>
-                      </a:solidFill>
-                    </a:lnB>
-                    <a:noFill/>
-                  </a:tcPr>
-                </a:tc>
-              </a:tr>
-              <a:tr h="323850">
-                <a:tc vMerge="1">
-                  <a:txBody>
-                    <a:bodyPr/>
-                    <a:lstStyle/>
-                    <a:p/>
-                  </a:txBody>
-                  <a:tcPr>
-                    <a:lnL w="9525">
-                      <a:solidFill>
-                        <a:srgbClr val="E6E8EB"/>
-                      </a:solidFill>
-                    </a:lnL>
-                    <a:lnR w="9525">
-                      <a:solidFill>
-                        <a:srgbClr val="E6E8EB"/>
-                      </a:solidFill>
-                    </a:lnR>
-                    <a:lnT w="9525">
-                      <a:solidFill>
-                        <a:srgbClr val="E6E8EB"/>
-                      </a:solidFill>
-                    </a:lnT>
-                    <a:lnB w="9525">
-                      <a:solidFill>
-                        <a:srgbClr val="E6E8EB"/>
-                      </a:solidFill>
-                    </a:lnB>
-                  </a:tcPr>
-                </a:tc>
-                <a:tc vMerge="1">
-                  <a:txBody>
-                    <a:bodyPr/>
-                    <a:lstStyle/>
-                    <a:p/>
-                  </a:txBody>
-                  <a:tcPr>
-                    <a:lnL w="9525">
-                      <a:solidFill>
-                        <a:srgbClr val="E6E8EB"/>
-                      </a:solidFill>
-                    </a:lnL>
-                    <a:lnR w="9525">
-                      <a:solidFill>
-                        <a:srgbClr val="E6E8EB"/>
-                      </a:solidFill>
-                    </a:lnR>
-                    <a:lnT w="9525">
-                      <a:solidFill>
-                        <a:srgbClr val="E6E8EB"/>
-                      </a:solidFill>
-                    </a:lnT>
-                    <a:lnB w="9525">
-                      <a:solidFill>
-                        <a:srgbClr val="E6E8EB"/>
-                      </a:solidFill>
-                    </a:lnB>
-                  </a:tcPr>
-                </a:tc>
-                <a:tc>
-                  <a:txBody>
-                    <a:bodyPr wrap="square"/>
-                    <a:lstStyle/>
-                    <a:p>
-                      <a:pPr algn="l">
-                        <a:defRPr sz="950"/>
-                      </a:pPr>
-                      <a:r>
-                        <a:rPr sz="950" b="1">
-                          <a:solidFill>
-                            <a:srgbClr val="11181C"/>
-                          </a:solidFill>
-                          <a:latin typeface="Arial"/>
-                        </a:rPr>
-                        <a:t>Ferrari main components</a:t>
-                      </a:r>
-                      <a:endParaRPr sz="950"/>
-                    </a:p>
-                  </a:txBody>
-                  <a:tcPr marL="50800" marR="50800" marT="25400" marB="25400" anchor="ctr">
-                    <a:lnL w="9525">
-                      <a:solidFill>
-                        <a:srgbClr val="E6E8EB"/>
-                      </a:solidFill>
-                    </a:lnL>
-                    <a:lnR w="9525">
-                      <a:solidFill>
-                        <a:srgbClr val="E6E8EB"/>
-                      </a:solidFill>
-                    </a:lnR>
-                    <a:lnT w="9525">
-                      <a:solidFill>
-                        <a:srgbClr val="E6E8EB"/>
-                      </a:solidFill>
-                    </a:lnT>
-                    <a:lnB w="9525">
-                      <a:solidFill>
-                        <a:srgbClr val="E6E8EB"/>
-                      </a:solidFill>
-                    </a:lnB>
-                    <a:noFill/>
-                  </a:tcPr>
-                </a:tc>
-                <a:tc>
-                  <a:txBody>
-                    <a:bodyPr wrap="square"/>
-                    <a:lstStyle/>
-                    <a:p>
-                      <a:pPr algn="l">
-                        <a:defRPr sz="950"/>
-                      </a:pPr>
-                      <a:r>
-                        <a:rPr sz="950" b="0">
-                          <a:solidFill>
-                            <a:srgbClr val="11181C"/>
-                          </a:solidFill>
-                          <a:latin typeface="Arial"/>
-                        </a:rPr>
-                        <a:t>Stock main components and spare parts in Malaysia.</a:t>
-                      </a:r>
-                      <a:endParaRPr sz="950"/>
-                    </a:p>
-                  </a:txBody>
-                  <a:tcPr marL="50800" marR="50800" marT="25400" marB="25400" anchor="ctr">
-                    <a:lnL w="9525">
-                      <a:solidFill>
-                        <a:srgbClr val="E6E8EB"/>
-                      </a:solidFill>
-                    </a:lnL>
-                    <a:lnR w="9525">
-                      <a:solidFill>
-                        <a:srgbClr val="E6E8EB"/>
-                      </a:solidFill>
-                    </a:lnR>
-                    <a:lnT w="9525">
-                      <a:solidFill>
-                        <a:srgbClr val="E6E8EB"/>
-                      </a:solidFill>
-                    </a:lnT>
-                    <a:lnB w="9525">
-                      <a:solidFill>
-                        <a:srgbClr val="E6E8EB"/>
-                      </a:solidFill>
-                    </a:lnB>
-                    <a:noFill/>
-                  </a:tcPr>
-                </a:tc>
-              </a:tr>
-              <a:tr h="323850">
-                <a:tc vMerge="1">
-                  <a:txBody>
-                    <a:bodyPr/>
-                    <a:lstStyle/>
-                    <a:p/>
-                  </a:txBody>
-                  <a:tcPr>
-                    <a:lnL w="9525">
-                      <a:solidFill>
-                        <a:srgbClr val="E6E8EB"/>
-                      </a:solidFill>
-                    </a:lnL>
-                    <a:lnR w="9525">
-                      <a:solidFill>
-                        <a:srgbClr val="E6E8EB"/>
-                      </a:solidFill>
-                    </a:lnR>
-                    <a:lnT w="9525">
-                      <a:solidFill>
-                        <a:srgbClr val="E6E8EB"/>
-                      </a:solidFill>
-                    </a:lnT>
-                    <a:lnB w="9525">
-                      <a:solidFill>
-                        <a:srgbClr val="E6E8EB"/>
-                      </a:solidFill>
-                    </a:lnB>
-                  </a:tcPr>
-                </a:tc>
-                <a:tc vMerge="1">
-                  <a:txBody>
-                    <a:bodyPr/>
-                    <a:lstStyle/>
-                    <a:p/>
-                  </a:txBody>
-                  <a:tcPr>
-                    <a:lnL w="9525">
-                      <a:solidFill>
-                        <a:srgbClr val="E6E8EB"/>
-                      </a:solidFill>
-                    </a:lnL>
-                    <a:lnR w="9525">
-                      <a:solidFill>
-                        <a:srgbClr val="E6E8EB"/>
-                      </a:solidFill>
-                    </a:lnR>
-                    <a:lnT w="9525">
-                      <a:solidFill>
-                        <a:srgbClr val="E6E8EB"/>
-                      </a:solidFill>
-                    </a:lnT>
-                    <a:lnB w="9525">
-                      <a:solidFill>
-                        <a:srgbClr val="E6E8EB"/>
-                      </a:solidFill>
-                    </a:lnB>
-                  </a:tcPr>
-                </a:tc>
-                <a:tc>
-                  <a:txBody>
-                    <a:bodyPr wrap="square"/>
-                    <a:lstStyle/>
-                    <a:p>
-                      <a:pPr algn="l">
-                        <a:defRPr sz="950"/>
-                      </a:pPr>
-                      <a:r>
-                        <a:rPr sz="950" b="1">
-                          <a:solidFill>
-                            <a:srgbClr val="11181C"/>
-                          </a:solidFill>
-                          <a:latin typeface="Arial"/>
-                        </a:rPr>
-                        <a:t>XCMG</a:t>
-                      </a:r>
-                      <a:endParaRPr sz="950"/>
-                    </a:p>
-                  </a:txBody>
-                  <a:tcPr marL="50800" marR="50800" marT="25400" marB="25400" anchor="ctr">
-                    <a:lnL w="9525">
-                      <a:solidFill>
-                        <a:srgbClr val="E6E8EB"/>
-                      </a:solidFill>
-                    </a:lnL>
-                    <a:lnR w="9525">
-                      <a:solidFill>
-                        <a:srgbClr val="E6E8EB"/>
-                      </a:solidFill>
-                    </a:lnR>
-                    <a:lnT w="9525">
-                      <a:solidFill>
-                        <a:srgbClr val="E6E8EB"/>
-                      </a:solidFill>
-                    </a:lnT>
-                    <a:lnB w="9525">
-                      <a:solidFill>
-                        <a:srgbClr val="E6E8EB"/>
-                      </a:solidFill>
-                    </a:lnB>
-                    <a:noFill/>
-                  </a:tcPr>
-                </a:tc>
-                <a:tc>
-                  <a:txBody>
-                    <a:bodyPr wrap="square"/>
-                    <a:lstStyle/>
-                    <a:p>
-                      <a:pPr algn="l">
-                        <a:defRPr sz="950"/>
-                      </a:pPr>
-                      <a:r>
-                        <a:rPr sz="950" b="0">
-                          <a:solidFill>
-                            <a:srgbClr val="11181C"/>
-                          </a:solidFill>
-                          <a:latin typeface="Arial"/>
-                        </a:rPr>
-                        <a:t>Agree supply terms with its official distributor, GM Tractors.</a:t>
-                      </a:r>
-                      <a:endParaRPr sz="950"/>
-                    </a:p>
-                  </a:txBody>
-                  <a:tcPr marL="50800" marR="50800" marT="25400" marB="25400" anchor="ctr">
-                    <a:lnL w="9525">
-                      <a:solidFill>
-                        <a:srgbClr val="E6E8EB"/>
-                      </a:solidFill>
-                    </a:lnL>
-                    <a:lnR w="9525">
-                      <a:solidFill>
-                        <a:srgbClr val="E6E8EB"/>
-                      </a:solidFill>
-                    </a:lnR>
-                    <a:lnT w="9525">
-                      <a:solidFill>
-                        <a:srgbClr val="E6E8EB"/>
-                      </a:solidFill>
-                    </a:lnT>
-                    <a:lnB w="9525">
-                      <a:solidFill>
-                        <a:srgbClr val="E6E8EB"/>
-                      </a:solidFill>
-                    </a:lnB>
-                    <a:noFill/>
-                  </a:tcPr>
-                </a:tc>
-              </a:tr>
-              <a:tr h="323850">
-                <a:tc rowSpan="2">
-                  <a:txBody>
-                    <a:bodyPr wrap="square"/>
-                    <a:lstStyle/>
-                    <a:p>
-                      <a:pPr algn="l">
-                        <a:defRPr sz="1100"/>
-                      </a:pPr>
-                      <a:r>
-                        <a:rPr sz="1100" b="1">
-                          <a:solidFill>
-                            <a:srgbClr val="076932"/>
-                          </a:solidFill>
-                          <a:latin typeface="Arial"/>
-                        </a:rPr>
-                        <a:t>Promotion</a:t>
-                      </a:r>
-                      <a:endParaRPr sz="1100"/>
-                    </a:p>
-                  </a:txBody>
-                  <a:tcPr marL="50800" marR="50800" marT="25400" marB="25400" anchor="ctr">
-                    <a:lnL w="9525">
-                      <a:solidFill>
-                        <a:srgbClr val="E6E8EB"/>
-                      </a:solidFill>
-                    </a:lnL>
-                    <a:lnR w="9525">
-                      <a:solidFill>
-                        <a:srgbClr val="E6E8EB"/>
-                      </a:solidFill>
-                    </a:lnR>
-                    <a:lnT w="9525">
-                      <a:solidFill>
-                        <a:srgbClr val="E6E8EB"/>
-                      </a:solidFill>
-                    </a:lnT>
-                    <a:lnB w="9525">
-                      <a:solidFill>
-                        <a:srgbClr val="E6E8EB"/>
-                      </a:solidFill>
-                    </a:lnB>
-                    <a:noFill/>
-                  </a:tcPr>
-                </a:tc>
-                <a:tc rowSpan="2">
-                  <a:txBody>
-                    <a:bodyPr wrap="square"/>
-                    <a:lstStyle/>
-                    <a:p>
-                      <a:pPr algn="l">
-                        <a:defRPr sz="1050"/>
-                      </a:pPr>
-                      <a:r>
-                        <a:rPr sz="1050" b="1">
-                          <a:solidFill>
-                            <a:srgbClr val="11181C"/>
-                          </a:solidFill>
-                          <a:latin typeface="Arial"/>
-                        </a:rPr>
-                        <a:t>Sell a ready-to-work package</a:t>
-                      </a:r>
-                      <a:endParaRPr sz="1050"/>
-                    </a:p>
-                  </a:txBody>
-                  <a:tcPr marL="50800" marR="50800" marT="25400" marB="25400" anchor="ctr">
-                    <a:lnL w="9525">
-                      <a:solidFill>
-                        <a:srgbClr val="E6E8EB"/>
-                      </a:solidFill>
-                    </a:lnL>
-                    <a:lnR w="9525">
-                      <a:solidFill>
-                        <a:srgbClr val="E6E8EB"/>
-                      </a:solidFill>
-                    </a:lnR>
-                    <a:lnT w="9525">
-                      <a:solidFill>
-                        <a:srgbClr val="E6E8EB"/>
-                      </a:solidFill>
-                    </a:lnT>
-                    <a:lnB w="9525">
-                      <a:solidFill>
-                        <a:srgbClr val="E6E8EB"/>
-                      </a:solidFill>
-                    </a:lnB>
-                    <a:noFill/>
-                  </a:tcPr>
-                </a:tc>
-                <a:tc>
-                  <a:txBody>
-                    <a:bodyPr wrap="square"/>
-                    <a:lstStyle/>
-                    <a:p>
-                      <a:pPr algn="l">
-                        <a:defRPr sz="950"/>
-                      </a:pPr>
-                      <a:r>
-                        <a:rPr sz="950" b="1">
-                          <a:solidFill>
-                            <a:srgbClr val="11181C"/>
-                          </a:solidFill>
-                          <a:latin typeface="Arial"/>
-                        </a:rPr>
-                        <a:t>Package</a:t>
-                      </a:r>
-                      <a:endParaRPr sz="950"/>
-                    </a:p>
-                  </a:txBody>
-                  <a:tcPr marL="50800" marR="50800" marT="25400" marB="25400" anchor="ctr">
-                    <a:lnL w="9525">
-                      <a:solidFill>
-                        <a:srgbClr val="E6E8EB"/>
-                      </a:solidFill>
-                    </a:lnL>
-                    <a:lnR w="9525">
-                      <a:solidFill>
-                        <a:srgbClr val="E6E8EB"/>
-                      </a:solidFill>
-                    </a:lnR>
-                    <a:lnT w="9525">
-                      <a:solidFill>
-                        <a:srgbClr val="E6E8EB"/>
-                      </a:solidFill>
-                    </a:lnT>
-                    <a:lnB w="9525">
-                      <a:solidFill>
-                        <a:srgbClr val="E6E8EB"/>
-                      </a:solidFill>
-                    </a:lnB>
-                    <a:noFill/>
-                  </a:tcPr>
-                </a:tc>
-                <a:tc>
-                  <a:txBody>
-                    <a:bodyPr wrap="square"/>
-                    <a:lstStyle/>
-                    <a:p>
-                      <a:pPr algn="l">
-                        <a:defRPr sz="950"/>
-                      </a:pPr>
-                      <a:r>
-                        <a:rPr sz="950" b="0">
-                          <a:solidFill>
-                            <a:srgbClr val="11181C"/>
-                          </a:solidFill>
-                          <a:latin typeface="Arial"/>
-                        </a:rPr>
-                        <a:t>Crane + flatdeck + installation as one offer; add a 2-year warranty on Ferrari.</a:t>
-                      </a:r>
-                      <a:endParaRPr sz="950"/>
-                    </a:p>
-                  </a:txBody>
-                  <a:tcPr marL="50800" marR="50800" marT="25400" marB="25400" anchor="ctr">
-                    <a:lnL w="9525">
-                      <a:solidFill>
-                        <a:srgbClr val="E6E8EB"/>
-                      </a:solidFill>
-                    </a:lnL>
-                    <a:lnR w="9525">
-                      <a:solidFill>
-                        <a:srgbClr val="E6E8EB"/>
-                      </a:solidFill>
-                    </a:lnR>
-                    <a:lnT w="9525">
-                      <a:solidFill>
-                        <a:srgbClr val="E6E8EB"/>
-                      </a:solidFill>
-                    </a:lnT>
-                    <a:lnB w="9525">
-                      <a:solidFill>
-                        <a:srgbClr val="E6E8EB"/>
-                      </a:solidFill>
-                    </a:lnB>
-                    <a:noFill/>
-                  </a:tcPr>
-                </a:tc>
-              </a:tr>
-              <a:tr h="323850">
-                <a:tc vMerge="1">
-                  <a:txBody>
-                    <a:bodyPr/>
-                    <a:lstStyle/>
-                    <a:p/>
-                  </a:txBody>
-                  <a:tcPr>
-                    <a:lnL w="9525">
-                      <a:solidFill>
-                        <a:srgbClr val="E6E8EB"/>
-                      </a:solidFill>
-                    </a:lnL>
-                    <a:lnR w="9525">
-                      <a:solidFill>
-                        <a:srgbClr val="E6E8EB"/>
-                      </a:solidFill>
-                    </a:lnR>
-                    <a:lnT w="9525">
-                      <a:solidFill>
-                        <a:srgbClr val="E6E8EB"/>
-                      </a:solidFill>
-                    </a:lnT>
-                    <a:lnB w="9525">
-                      <a:solidFill>
-                        <a:srgbClr val="E6E8EB"/>
-                      </a:solidFill>
-                    </a:lnB>
-                  </a:tcPr>
-                </a:tc>
-                <a:tc vMerge="1">
-                  <a:txBody>
-                    <a:bodyPr/>
-                    <a:lstStyle/>
-                    <a:p/>
-                  </a:txBody>
-                  <a:tcPr>
-                    <a:lnL w="9525">
-                      <a:solidFill>
-                        <a:srgbClr val="E6E8EB"/>
-                      </a:solidFill>
-                    </a:lnL>
-                    <a:lnR w="9525">
-                      <a:solidFill>
-                        <a:srgbClr val="E6E8EB"/>
-                      </a:solidFill>
-                    </a:lnR>
-                    <a:lnT w="9525">
-                      <a:solidFill>
-                        <a:srgbClr val="E6E8EB"/>
-                      </a:solidFill>
-                    </a:lnT>
-                    <a:lnB w="9525">
-                      <a:solidFill>
-                        <a:srgbClr val="E6E8EB"/>
-                      </a:solidFill>
-                    </a:lnB>
-                  </a:tcPr>
-                </a:tc>
-                <a:tc>
-                  <a:txBody>
-                    <a:bodyPr wrap="square"/>
-                    <a:lstStyle/>
-                    <a:p>
-                      <a:pPr algn="l">
-                        <a:defRPr sz="950"/>
-                      </a:pPr>
-                      <a:r>
-                        <a:rPr sz="950" b="1">
-                          <a:solidFill>
-                            <a:srgbClr val="11181C"/>
-                          </a:solidFill>
-                          <a:latin typeface="Arial"/>
-                        </a:rPr>
-                        <a:t>Exhibition and visits</a:t>
-                      </a:r>
-                      <a:endParaRPr sz="950"/>
-                    </a:p>
-                  </a:txBody>
-                  <a:tcPr marL="50800" marR="50800" marT="25400" marB="25400" anchor="ctr">
-                    <a:lnL w="9525">
-                      <a:solidFill>
-                        <a:srgbClr val="E6E8EB"/>
-                      </a:solidFill>
-                    </a:lnL>
-                    <a:lnR w="9525">
-                      <a:solidFill>
-                        <a:srgbClr val="E6E8EB"/>
-                      </a:solidFill>
-                    </a:lnR>
-                    <a:lnT w="9525">
-                      <a:solidFill>
-                        <a:srgbClr val="E6E8EB"/>
-                      </a:solidFill>
-                    </a:lnT>
-                    <a:lnB w="9525">
-                      <a:solidFill>
-                        <a:srgbClr val="E6E8EB"/>
-                      </a:solidFill>
-                    </a:lnB>
-                    <a:noFill/>
-                  </a:tcPr>
-                </a:tc>
-                <a:tc>
-                  <a:txBody>
-                    <a:bodyPr wrap="square"/>
-                    <a:lstStyle/>
-                    <a:p>
-                      <a:pPr algn="l">
-                        <a:defRPr sz="950"/>
-                      </a:pPr>
-                      <a:r>
-                        <a:rPr sz="950" b="0">
-                          <a:solidFill>
-                            <a:srgbClr val="11181C"/>
-                          </a:solidFill>
-                          <a:latin typeface="Arial"/>
-                        </a:rPr>
-                        <a:t>Show 268 A4 and FBR450R A4 at mining exhibitions and customer visits with a Marcom sales kit.</a:t>
+                        <a:t>Crane + flatdeck + installation (+2-year warranty on Ferrari). Exhibitions and customer visits with a Marcom sales kit.</a:t>
                       </a:r>
                       <a:endParaRPr sz="950"/>
                     </a:p>
@@ -7308,41 +5431,6 @@
           </a:graphicData>
         </a:graphic>
       </p:graphicFrame>
-      <p:sp>
-        <p:nvSpPr>
-          <p:cNvPr id="11" name="TextBox 10"/>
-          <p:cNvSpPr txBox="1"/>
-          <p:nvPr/>
-        </p:nvSpPr>
-        <p:spPr>
-          <a:xfrm>
-            <a:off x="533400" y="6305550"/>
-            <a:ext cx="11125200" cy="190500"/>
-          </a:xfrm>
-          <a:prstGeom prst="rect">
-            <a:avLst/>
-          </a:prstGeom>
-          <a:noFill/>
-        </p:spPr>
-        <p:txBody>
-          <a:bodyPr wrap="square" lIns="0" rIns="0" tIns="0" bIns="0" anchor="t">
-            <a:spAutoFit/>
-          </a:bodyPr>
-          <a:lstStyle/>
-          <a:p>
-            <a:pPr algn="l"/>
-            <a:r>
-              <a:rPr sz="850" b="0" i="0">
-                <a:solidFill>
-                  <a:srgbClr val="697177"/>
-                </a:solidFill>
-                <a:latin typeface="Arial"/>
-              </a:rPr>
-              <a:t>* Meaning of PB, RS and ECM to be confirmed with the F.lli Ferrari datasheet. Price gaps vs the Top 1 model in each tm tier (2023 – Aug 2026 import prices).</a:t>
-            </a:r>
-          </a:p>
-        </p:txBody>
-      </p:sp>
     </p:spTree>
   </p:cSld>
   <p:clrMapOvr>

</xml_diff>